<commit_message>
Add editable progress charts and set production completion to 30 percent
</commit_message>
<xml_diff>
--- a/Proje_Sunumu.pptx
+++ b/Proje_Sunumu.pptx
@@ -2,14 +2,14 @@
 <file path=ppt/presentation.xml><?xml version="1.0" encoding="utf-8"?>
 <p:presentation xmlns:p="http://schemas.openxmlformats.org/presentationml/2006/main">
   <p:sldMasterIdLst>
-    <p:sldMasterId xmlns:r="http://schemas.openxmlformats.org/officeDocument/2006/relationships" id="2147483648" r:id="Rf6c8b66130844547"/>
+    <p:sldMasterId xmlns:r="http://schemas.openxmlformats.org/officeDocument/2006/relationships" id="2147483648" r:id="R1c86afdf67e843da"/>
   </p:sldMasterIdLst>
   <p:notesMasterIdLst>
-    <p:notesMasterId xmlns:r="http://schemas.openxmlformats.org/officeDocument/2006/relationships" r:id="R2ca494e31cbe4ad1"/>
+    <p:notesMasterId xmlns:r="http://schemas.openxmlformats.org/officeDocument/2006/relationships" r:id="R76d2483fd7bc4970"/>
   </p:notesMasterIdLst>
   <p:sldIdLst>
-    <p:sldId xmlns:r="http://schemas.openxmlformats.org/officeDocument/2006/relationships" id="256" r:id="Rb190d78f6bc340fc"/>
-    <p:sldId xmlns:r="http://schemas.openxmlformats.org/officeDocument/2006/relationships" id="257" r:id="R9d1ac26d03674c2c"/>
+    <p:sldId xmlns:r="http://schemas.openxmlformats.org/officeDocument/2006/relationships" id="256" r:id="R1b5e7b6de87249b0"/>
+    <p:sldId xmlns:r="http://schemas.openxmlformats.org/officeDocument/2006/relationships" id="257" r:id="R4581683affed4029"/>
   </p:sldIdLst>
   <p:sldSz cx="15240000" cy="8572500"/>
   <p:notesSz cx="6858000" cy="9144000"/>
@@ -446,6 +446,11 @@
               <a:t>Kurgusal örnekler, önceki proje takvimi çalışma kitabındaki sayısal özetlerden alınmıştır. Üç projenin proje yöneticisi bu sade örnekte Ayşe Yılmaz olarak birleştirilmiştir. Finans satırlarında tahmini toplam gerçek efor, gerçek alım, kalan efor ve kalan alım toplamıdır. Bütçe farkı bütçe eksi tahmini toplamdır. Birim bazındaki saatler önceki Efor kayıtlarından toplanmıştır. Kişi sayıları projelere özeldir ve projeler arasında toplanarak benzersiz kişi sayısı elde edilemez.</a:t>
             </a:r>
           </a:p>
+          <a:p xmlns:a="http://schemas.openxmlformats.org/drawingml/2006/main">
+            <a:r>
+              <a:t>Bu sürümde kullanıcı isteğiyle Üretim Hattı tamamlanma oranı yüzde 30 olarak güncellenmiştir. Diğer proje verileri örnektir. Karşılaştırma grafiği düzenlenebilir yerel PowerPoint grafiğidir. Verileri Düzenle penceresinde değerler 0–100 ölçeğindedir. 30 yazmak yüzde 30 anlamına gelir. Grafik değerleri değiştirilince tablolar otomatik eşitlenmez; tablo yüzdesi ayrıca güncellenmelidir.</a:t>
+            </a:r>
+          </a:p>
         </p:txBody>
       </p:sp>
       <p:sp>
@@ -514,6 +519,11 @@
           <a:p xmlns:a="http://schemas.openxmlformats.org/drawingml/2006/main">
             <a:r>
               <a:t>Yapılanlar, sıradaki işler ve üst yönetimden BEKLENTİ alanları örnek olarak yazılmıştır. Müşteri Portalı için 121 bin TL ek bütçe talebi, 120.550 TL tahmini bütçe aşımının yukarı yuvarlanmış örnek talebidir. Yönetici toplantıdan önce metinleri, karar mercilerini, tarihleri ve etkileri kendi projelerine göre düzenlemelidir. PowerPoint ve Excel arasında otomatik veri bağlantısı yoktur. Tablolar PowerPoint içinde ayrı ayrı düzenlenebilir.</a:t>
+            </a:r>
+          </a:p>
+          <a:p xmlns:a="http://schemas.openxmlformats.org/drawingml/2006/main">
+            <a:r>
+              <a:t>Haftalık üretim grafiğinin yalnızca ilk haftası kullanıcı tarafından belirtilen yüzde 30 değeridir. Geçmiş haftalar için oran verilmediğinden değer uydurulmamıştır. Artış veya azalışı izlemek için önceki haftayı koruyup veri tablosuna sonraki hafta ve oranı ekleyin. Mavi kaynak aralığını yeni satırları kapsayacak şekilde genişletin. İki grafiğin gömülü veri tabloları ayrıdır; güncel oran grafiği ve haftalık kayıt ayrı ayrı güncellenir. Yüzde işareti olmadan 0–100 arasında sayı girin.</a:t>
             </a:r>
           </a:p>
         </p:txBody>
@@ -611,6 +621,7 @@
                 <a:spcPts val="0"/>
               </a:spcAft>
               <a:buNone/>
+              <a:defRPr/>
             </a:lvl1pPr>
             <a:lvl2pPr marL="0" indent="0">
               <a:lnSpc>
@@ -623,6 +634,7 @@
                 <a:spcPts val="0"/>
               </a:spcAft>
               <a:buNone/>
+              <a:defRPr/>
             </a:lvl2pPr>
             <a:lvl3pPr marL="0" indent="0">
               <a:lnSpc>
@@ -635,6 +647,7 @@
                 <a:spcPts val="0"/>
               </a:spcAft>
               <a:buNone/>
+              <a:defRPr/>
             </a:lvl3pPr>
             <a:lvl4pPr marL="0" indent="0">
               <a:lnSpc>
@@ -647,6 +660,7 @@
                 <a:spcPts val="0"/>
               </a:spcAft>
               <a:buNone/>
+              <a:defRPr/>
             </a:lvl4pPr>
             <a:lvl5pPr marL="0" indent="0">
               <a:lnSpc>
@@ -659,6 +673,7 @@
                 <a:spcPts val="0"/>
               </a:spcAft>
               <a:buNone/>
+              <a:defRPr/>
             </a:lvl5pPr>
             <a:lvl6pPr marL="0" indent="0">
               <a:lnSpc>
@@ -671,6 +686,7 @@
                 <a:spcPts val="0"/>
               </a:spcAft>
               <a:buNone/>
+              <a:defRPr/>
             </a:lvl6pPr>
             <a:lvl7pPr marL="0" indent="0">
               <a:lnSpc>
@@ -683,6 +699,7 @@
                 <a:spcPts val="0"/>
               </a:spcAft>
               <a:buNone/>
+              <a:defRPr/>
             </a:lvl7pPr>
             <a:lvl8pPr marL="0" indent="0">
               <a:lnSpc>
@@ -695,6 +712,7 @@
                 <a:spcPts val="0"/>
               </a:spcAft>
               <a:buNone/>
+              <a:defRPr/>
             </a:lvl8pPr>
             <a:lvl9pPr marL="0" indent="0">
               <a:lnSpc>
@@ -707,6 +725,7 @@
                 <a:spcPts val="0"/>
               </a:spcAft>
               <a:buNone/>
+              <a:defRPr/>
             </a:lvl9pPr>
           </a:lstStyle>
           <a:p xmlns:a="http://schemas.openxmlformats.org/drawingml/2006/main"/>
@@ -768,6 +787,7 @@
                 <a:spcPts val="0"/>
               </a:spcAft>
               <a:buNone/>
+              <a:defRPr/>
             </a:lvl1pPr>
             <a:lvl2pPr marL="0" indent="0">
               <a:lnSpc>
@@ -780,6 +800,7 @@
                 <a:spcPts val="0"/>
               </a:spcAft>
               <a:buNone/>
+              <a:defRPr/>
             </a:lvl2pPr>
             <a:lvl3pPr marL="0" indent="0">
               <a:lnSpc>
@@ -792,6 +813,7 @@
                 <a:spcPts val="0"/>
               </a:spcAft>
               <a:buNone/>
+              <a:defRPr/>
             </a:lvl3pPr>
             <a:lvl4pPr marL="0" indent="0">
               <a:lnSpc>
@@ -804,6 +826,7 @@
                 <a:spcPts val="0"/>
               </a:spcAft>
               <a:buNone/>
+              <a:defRPr/>
             </a:lvl4pPr>
             <a:lvl5pPr marL="0" indent="0">
               <a:lnSpc>
@@ -816,6 +839,7 @@
                 <a:spcPts val="0"/>
               </a:spcAft>
               <a:buNone/>
+              <a:defRPr/>
             </a:lvl5pPr>
             <a:lvl6pPr marL="0" indent="0">
               <a:lnSpc>
@@ -828,6 +852,7 @@
                 <a:spcPts val="0"/>
               </a:spcAft>
               <a:buNone/>
+              <a:defRPr/>
             </a:lvl6pPr>
             <a:lvl7pPr marL="0" indent="0">
               <a:lnSpc>
@@ -840,6 +865,7 @@
                 <a:spcPts val="0"/>
               </a:spcAft>
               <a:buNone/>
+              <a:defRPr/>
             </a:lvl7pPr>
             <a:lvl8pPr marL="0" indent="0">
               <a:lnSpc>
@@ -852,6 +878,7 @@
                 <a:spcPts val="0"/>
               </a:spcAft>
               <a:buNone/>
+              <a:defRPr/>
             </a:lvl8pPr>
             <a:lvl9pPr marL="0" indent="0">
               <a:lnSpc>
@@ -864,6 +891,7 @@
                 <a:spcPts val="0"/>
               </a:spcAft>
               <a:buNone/>
+              <a:defRPr/>
             </a:lvl9pPr>
           </a:lstStyle>
           <a:p xmlns:a="http://schemas.openxmlformats.org/drawingml/2006/main"/>
@@ -942,6 +970,7 @@
                 <a:spcPts val="0"/>
               </a:spcAft>
               <a:buNone/>
+              <a:defRPr/>
             </a:lvl1pPr>
             <a:lvl2pPr marL="0" indent="0">
               <a:lnSpc>
@@ -954,6 +983,7 @@
                 <a:spcPts val="0"/>
               </a:spcAft>
               <a:buNone/>
+              <a:defRPr/>
             </a:lvl2pPr>
             <a:lvl3pPr marL="0" indent="0">
               <a:lnSpc>
@@ -966,6 +996,7 @@
                 <a:spcPts val="0"/>
               </a:spcAft>
               <a:buNone/>
+              <a:defRPr/>
             </a:lvl3pPr>
             <a:lvl4pPr marL="0" indent="0">
               <a:lnSpc>
@@ -978,6 +1009,7 @@
                 <a:spcPts val="0"/>
               </a:spcAft>
               <a:buNone/>
+              <a:defRPr/>
             </a:lvl4pPr>
             <a:lvl5pPr marL="0" indent="0">
               <a:lnSpc>
@@ -990,6 +1022,7 @@
                 <a:spcPts val="0"/>
               </a:spcAft>
               <a:buNone/>
+              <a:defRPr/>
             </a:lvl5pPr>
             <a:lvl6pPr marL="0" indent="0">
               <a:lnSpc>
@@ -1002,6 +1035,7 @@
                 <a:spcPts val="0"/>
               </a:spcAft>
               <a:buNone/>
+              <a:defRPr/>
             </a:lvl6pPr>
             <a:lvl7pPr marL="0" indent="0">
               <a:lnSpc>
@@ -1014,6 +1048,7 @@
                 <a:spcPts val="0"/>
               </a:spcAft>
               <a:buNone/>
+              <a:defRPr/>
             </a:lvl7pPr>
             <a:lvl8pPr marL="0" indent="0">
               <a:lnSpc>
@@ -1026,6 +1061,7 @@
                 <a:spcPts val="0"/>
               </a:spcAft>
               <a:buNone/>
+              <a:defRPr/>
             </a:lvl8pPr>
             <a:lvl9pPr marL="0" indent="0">
               <a:lnSpc>
@@ -1038,6 +1074,7 @@
                 <a:spcPts val="0"/>
               </a:spcAft>
               <a:buNone/>
+              <a:defRPr/>
             </a:lvl9pPr>
           </a:lstStyle>
           <a:p xmlns:a="http://schemas.openxmlformats.org/drawingml/2006/main"/>
@@ -1116,6 +1153,7 @@
                 <a:spcPts val="0"/>
               </a:spcAft>
               <a:buNone/>
+              <a:defRPr/>
             </a:lvl1pPr>
             <a:lvl2pPr marL="0" indent="0">
               <a:lnSpc>
@@ -1128,6 +1166,7 @@
                 <a:spcPts val="0"/>
               </a:spcAft>
               <a:buNone/>
+              <a:defRPr/>
             </a:lvl2pPr>
             <a:lvl3pPr marL="0" indent="0">
               <a:lnSpc>
@@ -1140,6 +1179,7 @@
                 <a:spcPts val="0"/>
               </a:spcAft>
               <a:buNone/>
+              <a:defRPr/>
             </a:lvl3pPr>
             <a:lvl4pPr marL="0" indent="0">
               <a:lnSpc>
@@ -1152,6 +1192,7 @@
                 <a:spcPts val="0"/>
               </a:spcAft>
               <a:buNone/>
+              <a:defRPr/>
             </a:lvl4pPr>
             <a:lvl5pPr marL="0" indent="0">
               <a:lnSpc>
@@ -1164,6 +1205,7 @@
                 <a:spcPts val="0"/>
               </a:spcAft>
               <a:buNone/>
+              <a:defRPr/>
             </a:lvl5pPr>
             <a:lvl6pPr marL="0" indent="0">
               <a:lnSpc>
@@ -1176,6 +1218,7 @@
                 <a:spcPts val="0"/>
               </a:spcAft>
               <a:buNone/>
+              <a:defRPr/>
             </a:lvl6pPr>
             <a:lvl7pPr marL="0" indent="0">
               <a:lnSpc>
@@ -1188,6 +1231,7 @@
                 <a:spcPts val="0"/>
               </a:spcAft>
               <a:buNone/>
+              <a:defRPr/>
             </a:lvl7pPr>
             <a:lvl8pPr marL="0" indent="0">
               <a:lnSpc>
@@ -1200,6 +1244,7 @@
                 <a:spcPts val="0"/>
               </a:spcAft>
               <a:buNone/>
+              <a:defRPr/>
             </a:lvl8pPr>
             <a:lvl9pPr marL="0" indent="0">
               <a:lnSpc>
@@ -1212,6 +1257,7 @@
                 <a:spcPts val="0"/>
               </a:spcAft>
               <a:buNone/>
+              <a:defRPr/>
             </a:lvl9pPr>
           </a:lstStyle>
           <a:p xmlns:a="http://schemas.openxmlformats.org/drawingml/2006/main"/>
@@ -1273,6 +1319,7 @@
                 <a:spcPts val="1500"/>
               </a:spcAft>
               <a:buChar char="•"/>
+              <a:defRPr/>
             </a:lvl1pPr>
             <a:lvl2pPr marL="666750" indent="-285750">
               <a:lnSpc>
@@ -1285,6 +1332,7 @@
                 <a:spcPts val="1500"/>
               </a:spcAft>
               <a:buChar char="•"/>
+              <a:defRPr/>
             </a:lvl2pPr>
             <a:lvl3pPr marL="1047750" indent="-285750">
               <a:lnSpc>
@@ -1297,6 +1345,7 @@
                 <a:spcPts val="1500"/>
               </a:spcAft>
               <a:buChar char="•"/>
+              <a:defRPr/>
             </a:lvl3pPr>
             <a:lvl4pPr marL="1428750" indent="-285750">
               <a:lnSpc>
@@ -1309,6 +1358,7 @@
                 <a:spcPts val="1500"/>
               </a:spcAft>
               <a:buChar char="•"/>
+              <a:defRPr/>
             </a:lvl4pPr>
             <a:lvl5pPr marL="1809750" indent="-285750">
               <a:lnSpc>
@@ -1321,6 +1371,7 @@
                 <a:spcPts val="1500"/>
               </a:spcAft>
               <a:buChar char="•"/>
+              <a:defRPr/>
             </a:lvl5pPr>
             <a:lvl6pPr marL="2190750" indent="-285750">
               <a:lnSpc>
@@ -1333,6 +1384,7 @@
                 <a:spcPts val="1500"/>
               </a:spcAft>
               <a:buChar char="•"/>
+              <a:defRPr/>
             </a:lvl6pPr>
             <a:lvl7pPr marL="2571750" indent="-285750">
               <a:lnSpc>
@@ -1345,6 +1397,7 @@
                 <a:spcPts val="1500"/>
               </a:spcAft>
               <a:buChar char="•"/>
+              <a:defRPr/>
             </a:lvl7pPr>
             <a:lvl8pPr marL="2952750" indent="-285750">
               <a:lnSpc>
@@ -1357,6 +1410,7 @@
                 <a:spcPts val="1500"/>
               </a:spcAft>
               <a:buChar char="•"/>
+              <a:defRPr/>
             </a:lvl8pPr>
             <a:lvl9pPr marL="3333750" indent="-285750">
               <a:lnSpc>
@@ -1369,6 +1423,7 @@
                 <a:spcPts val="1500"/>
               </a:spcAft>
               <a:buChar char="•"/>
+              <a:defRPr/>
             </a:lvl9pPr>
           </a:lstStyle>
           <a:p xmlns:a="http://schemas.openxmlformats.org/drawingml/2006/main"/>
@@ -1447,6 +1502,7 @@
                 <a:spcPts val="0"/>
               </a:spcAft>
               <a:buNone/>
+              <a:defRPr/>
             </a:lvl1pPr>
             <a:lvl2pPr marL="0" indent="0">
               <a:lnSpc>
@@ -1459,6 +1515,7 @@
                 <a:spcPts val="0"/>
               </a:spcAft>
               <a:buNone/>
+              <a:defRPr/>
             </a:lvl2pPr>
             <a:lvl3pPr marL="0" indent="0">
               <a:lnSpc>
@@ -1471,6 +1528,7 @@
                 <a:spcPts val="0"/>
               </a:spcAft>
               <a:buNone/>
+              <a:defRPr/>
             </a:lvl3pPr>
             <a:lvl4pPr marL="0" indent="0">
               <a:lnSpc>
@@ -1483,6 +1541,7 @@
                 <a:spcPts val="0"/>
               </a:spcAft>
               <a:buNone/>
+              <a:defRPr/>
             </a:lvl4pPr>
             <a:lvl5pPr marL="0" indent="0">
               <a:lnSpc>
@@ -1495,6 +1554,7 @@
                 <a:spcPts val="0"/>
               </a:spcAft>
               <a:buNone/>
+              <a:defRPr/>
             </a:lvl5pPr>
             <a:lvl6pPr marL="0" indent="0">
               <a:lnSpc>
@@ -1507,6 +1567,7 @@
                 <a:spcPts val="0"/>
               </a:spcAft>
               <a:buNone/>
+              <a:defRPr/>
             </a:lvl6pPr>
             <a:lvl7pPr marL="0" indent="0">
               <a:lnSpc>
@@ -1519,6 +1580,7 @@
                 <a:spcPts val="0"/>
               </a:spcAft>
               <a:buNone/>
+              <a:defRPr/>
             </a:lvl7pPr>
             <a:lvl8pPr marL="0" indent="0">
               <a:lnSpc>
@@ -1531,6 +1593,7 @@
                 <a:spcPts val="0"/>
               </a:spcAft>
               <a:buNone/>
+              <a:defRPr/>
             </a:lvl8pPr>
             <a:lvl9pPr marL="0" indent="0">
               <a:lnSpc>
@@ -1543,6 +1606,7 @@
                 <a:spcPts val="0"/>
               </a:spcAft>
               <a:buNone/>
+              <a:defRPr/>
             </a:lvl9pPr>
           </a:lstStyle>
           <a:p xmlns:a="http://schemas.openxmlformats.org/drawingml/2006/main"/>
@@ -1604,6 +1668,7 @@
                 <a:spcPts val="1500"/>
               </a:spcAft>
               <a:buChar char="•"/>
+              <a:defRPr/>
             </a:lvl1pPr>
             <a:lvl2pPr marL="666750" indent="-285750">
               <a:lnSpc>
@@ -1616,6 +1681,7 @@
                 <a:spcPts val="1500"/>
               </a:spcAft>
               <a:buChar char="•"/>
+              <a:defRPr/>
             </a:lvl2pPr>
             <a:lvl3pPr marL="1047750" indent="-285750">
               <a:lnSpc>
@@ -1628,6 +1694,7 @@
                 <a:spcPts val="1500"/>
               </a:spcAft>
               <a:buChar char="•"/>
+              <a:defRPr/>
             </a:lvl3pPr>
             <a:lvl4pPr marL="1428750" indent="-285750">
               <a:lnSpc>
@@ -1640,6 +1707,7 @@
                 <a:spcPts val="1500"/>
               </a:spcAft>
               <a:buChar char="•"/>
+              <a:defRPr/>
             </a:lvl4pPr>
             <a:lvl5pPr marL="1809750" indent="-285750">
               <a:lnSpc>
@@ -1652,6 +1720,7 @@
                 <a:spcPts val="1500"/>
               </a:spcAft>
               <a:buChar char="•"/>
+              <a:defRPr/>
             </a:lvl5pPr>
             <a:lvl6pPr marL="2190750" indent="-285750">
               <a:lnSpc>
@@ -1664,6 +1733,7 @@
                 <a:spcPts val="1500"/>
               </a:spcAft>
               <a:buChar char="•"/>
+              <a:defRPr/>
             </a:lvl6pPr>
             <a:lvl7pPr marL="2571750" indent="-285750">
               <a:lnSpc>
@@ -1676,6 +1746,7 @@
                 <a:spcPts val="1500"/>
               </a:spcAft>
               <a:buChar char="•"/>
+              <a:defRPr/>
             </a:lvl7pPr>
             <a:lvl8pPr marL="2952750" indent="-285750">
               <a:lnSpc>
@@ -1688,6 +1759,7 @@
                 <a:spcPts val="1500"/>
               </a:spcAft>
               <a:buChar char="•"/>
+              <a:defRPr/>
             </a:lvl8pPr>
             <a:lvl9pPr marL="3333750" indent="-285750">
               <a:lnSpc>
@@ -1700,6 +1772,7 @@
                 <a:spcPts val="1500"/>
               </a:spcAft>
               <a:buChar char="•"/>
+              <a:defRPr/>
             </a:lvl9pPr>
           </a:lstStyle>
           <a:p xmlns:a="http://schemas.openxmlformats.org/drawingml/2006/main"/>
@@ -1761,6 +1834,7 @@
                 <a:spcPts val="1500"/>
               </a:spcAft>
               <a:buChar char="•"/>
+              <a:defRPr/>
             </a:lvl1pPr>
             <a:lvl2pPr marL="666750" indent="-285750">
               <a:lnSpc>
@@ -1773,6 +1847,7 @@
                 <a:spcPts val="1500"/>
               </a:spcAft>
               <a:buChar char="•"/>
+              <a:defRPr/>
             </a:lvl2pPr>
             <a:lvl3pPr marL="1047750" indent="-285750">
               <a:lnSpc>
@@ -1785,6 +1860,7 @@
                 <a:spcPts val="1500"/>
               </a:spcAft>
               <a:buChar char="•"/>
+              <a:defRPr/>
             </a:lvl3pPr>
             <a:lvl4pPr marL="1428750" indent="-285750">
               <a:lnSpc>
@@ -1797,6 +1873,7 @@
                 <a:spcPts val="1500"/>
               </a:spcAft>
               <a:buChar char="•"/>
+              <a:defRPr/>
             </a:lvl4pPr>
             <a:lvl5pPr marL="1809750" indent="-285750">
               <a:lnSpc>
@@ -1809,6 +1886,7 @@
                 <a:spcPts val="1500"/>
               </a:spcAft>
               <a:buChar char="•"/>
+              <a:defRPr/>
             </a:lvl5pPr>
             <a:lvl6pPr marL="2190750" indent="-285750">
               <a:lnSpc>
@@ -1821,6 +1899,7 @@
                 <a:spcPts val="1500"/>
               </a:spcAft>
               <a:buChar char="•"/>
+              <a:defRPr/>
             </a:lvl6pPr>
             <a:lvl7pPr marL="2571750" indent="-285750">
               <a:lnSpc>
@@ -1833,6 +1912,7 @@
                 <a:spcPts val="1500"/>
               </a:spcAft>
               <a:buChar char="•"/>
+              <a:defRPr/>
             </a:lvl7pPr>
             <a:lvl8pPr marL="2952750" indent="-285750">
               <a:lnSpc>
@@ -1845,6 +1925,7 @@
                 <a:spcPts val="1500"/>
               </a:spcAft>
               <a:buChar char="•"/>
+              <a:defRPr/>
             </a:lvl8pPr>
             <a:lvl9pPr marL="3333750" indent="-285750">
               <a:lnSpc>
@@ -1857,6 +1938,7 @@
                 <a:spcPts val="1500"/>
               </a:spcAft>
               <a:buChar char="•"/>
+              <a:defRPr/>
             </a:lvl9pPr>
           </a:lstStyle>
           <a:p xmlns:a="http://schemas.openxmlformats.org/drawingml/2006/main"/>
@@ -1935,6 +2017,7 @@
                 <a:spcPts val="0"/>
               </a:spcAft>
               <a:buNone/>
+              <a:defRPr/>
             </a:lvl1pPr>
             <a:lvl2pPr marL="0" indent="0">
               <a:lnSpc>
@@ -1947,6 +2030,7 @@
                 <a:spcPts val="0"/>
               </a:spcAft>
               <a:buNone/>
+              <a:defRPr/>
             </a:lvl2pPr>
             <a:lvl3pPr marL="0" indent="0">
               <a:lnSpc>
@@ -1959,6 +2043,7 @@
                 <a:spcPts val="0"/>
               </a:spcAft>
               <a:buNone/>
+              <a:defRPr/>
             </a:lvl3pPr>
             <a:lvl4pPr marL="0" indent="0">
               <a:lnSpc>
@@ -1971,6 +2056,7 @@
                 <a:spcPts val="0"/>
               </a:spcAft>
               <a:buNone/>
+              <a:defRPr/>
             </a:lvl4pPr>
             <a:lvl5pPr marL="0" indent="0">
               <a:lnSpc>
@@ -1983,6 +2069,7 @@
                 <a:spcPts val="0"/>
               </a:spcAft>
               <a:buNone/>
+              <a:defRPr/>
             </a:lvl5pPr>
             <a:lvl6pPr marL="0" indent="0">
               <a:lnSpc>
@@ -1995,6 +2082,7 @@
                 <a:spcPts val="0"/>
               </a:spcAft>
               <a:buNone/>
+              <a:defRPr/>
             </a:lvl6pPr>
             <a:lvl7pPr marL="0" indent="0">
               <a:lnSpc>
@@ -2007,6 +2095,7 @@
                 <a:spcPts val="0"/>
               </a:spcAft>
               <a:buNone/>
+              <a:defRPr/>
             </a:lvl7pPr>
             <a:lvl8pPr marL="0" indent="0">
               <a:lnSpc>
@@ -2019,6 +2108,7 @@
                 <a:spcPts val="0"/>
               </a:spcAft>
               <a:buNone/>
+              <a:defRPr/>
             </a:lvl8pPr>
             <a:lvl9pPr marL="0" indent="0">
               <a:lnSpc>
@@ -2031,6 +2121,7 @@
                 <a:spcPts val="0"/>
               </a:spcAft>
               <a:buNone/>
+              <a:defRPr/>
             </a:lvl9pPr>
           </a:lstStyle>
           <a:p xmlns:a="http://schemas.openxmlformats.org/drawingml/2006/main"/>
@@ -2092,6 +2183,7 @@
                 <a:spcPts val="1500"/>
               </a:spcAft>
               <a:buChar char="•"/>
+              <a:defRPr/>
             </a:lvl1pPr>
             <a:lvl2pPr marL="666750" indent="-285750">
               <a:lnSpc>
@@ -2104,6 +2196,7 @@
                 <a:spcPts val="1500"/>
               </a:spcAft>
               <a:buChar char="•"/>
+              <a:defRPr/>
             </a:lvl2pPr>
             <a:lvl3pPr marL="1047750" indent="-285750">
               <a:lnSpc>
@@ -2116,6 +2209,7 @@
                 <a:spcPts val="1500"/>
               </a:spcAft>
               <a:buChar char="•"/>
+              <a:defRPr/>
             </a:lvl3pPr>
             <a:lvl4pPr marL="1428750" indent="-285750">
               <a:lnSpc>
@@ -2128,6 +2222,7 @@
                 <a:spcPts val="1500"/>
               </a:spcAft>
               <a:buChar char="•"/>
+              <a:defRPr/>
             </a:lvl4pPr>
             <a:lvl5pPr marL="1809750" indent="-285750">
               <a:lnSpc>
@@ -2140,6 +2235,7 @@
                 <a:spcPts val="1500"/>
               </a:spcAft>
               <a:buChar char="•"/>
+              <a:defRPr/>
             </a:lvl5pPr>
             <a:lvl6pPr marL="2190750" indent="-285750">
               <a:lnSpc>
@@ -2152,6 +2248,7 @@
                 <a:spcPts val="1500"/>
               </a:spcAft>
               <a:buChar char="•"/>
+              <a:defRPr/>
             </a:lvl6pPr>
             <a:lvl7pPr marL="2571750" indent="-285750">
               <a:lnSpc>
@@ -2164,6 +2261,7 @@
                 <a:spcPts val="1500"/>
               </a:spcAft>
               <a:buChar char="•"/>
+              <a:defRPr/>
             </a:lvl7pPr>
             <a:lvl8pPr marL="2952750" indent="-285750">
               <a:lnSpc>
@@ -2176,6 +2274,7 @@
                 <a:spcPts val="1500"/>
               </a:spcAft>
               <a:buChar char="•"/>
+              <a:defRPr/>
             </a:lvl8pPr>
             <a:lvl9pPr marL="3333750" indent="-285750">
               <a:lnSpc>
@@ -2188,6 +2287,7 @@
                 <a:spcPts val="1500"/>
               </a:spcAft>
               <a:buChar char="•"/>
+              <a:defRPr/>
             </a:lvl9pPr>
           </a:lstStyle>
           <a:p xmlns:a="http://schemas.openxmlformats.org/drawingml/2006/main"/>
@@ -2236,12 +2336,12 @@
   </p:cSld>
   <p:clrMap bg1="lt1" tx1="dk1" bg2="lt2" tx2="dk2" accent1="accent1" accent2="accent2" accent3="accent3" accent4="accent4" accent5="accent5" accent6="accent6" hlink="hlink" folHlink="folHlink"/>
   <p:sldLayoutIdLst>
-    <p:sldLayoutId xmlns:r="http://schemas.openxmlformats.org/officeDocument/2006/relationships" id="2147483649" r:id="Re2f9757d460d4266"/>
-    <p:sldLayoutId xmlns:r="http://schemas.openxmlformats.org/officeDocument/2006/relationships" id="2147483650" r:id="Rb79e3066efe2428a"/>
-    <p:sldLayoutId xmlns:r="http://schemas.openxmlformats.org/officeDocument/2006/relationships" id="2147483651" r:id="Rd537f752220447c9"/>
-    <p:sldLayoutId xmlns:r="http://schemas.openxmlformats.org/officeDocument/2006/relationships" id="2147483652" r:id="R03e09f06215246f8"/>
-    <p:sldLayoutId xmlns:r="http://schemas.openxmlformats.org/officeDocument/2006/relationships" id="2147483653" r:id="Ree156eb9ab814b22"/>
-    <p:sldLayoutId xmlns:r="http://schemas.openxmlformats.org/officeDocument/2006/relationships" id="2147483654" r:id="Re39328faf7b64a91"/>
+    <p:sldLayoutId xmlns:r="http://schemas.openxmlformats.org/officeDocument/2006/relationships" id="2147483649" r:id="R091122e75aa948ac"/>
+    <p:sldLayoutId xmlns:r="http://schemas.openxmlformats.org/officeDocument/2006/relationships" id="2147483650" r:id="Rd8dabf942a2c4b3e"/>
+    <p:sldLayoutId xmlns:r="http://schemas.openxmlformats.org/officeDocument/2006/relationships" id="2147483651" r:id="R9cdcf14d686f44d7"/>
+    <p:sldLayoutId xmlns:r="http://schemas.openxmlformats.org/officeDocument/2006/relationships" id="2147483652" r:id="R46e1ee4befd94780"/>
+    <p:sldLayoutId xmlns:r="http://schemas.openxmlformats.org/officeDocument/2006/relationships" id="2147483653" r:id="R1d4afca77db047cd"/>
+    <p:sldLayoutId xmlns:r="http://schemas.openxmlformats.org/officeDocument/2006/relationships" id="2147483654" r:id="R25ccfae4c0cf482d"/>
   </p:sldLayoutIdLst>
   <p:txStyles>
     <p:titleStyle>
@@ -2768,6 +2868,532 @@
 </a:theme>
 </file>
 
+<file path=ppt/slides/charts/chart1.xml><?xml version="1.0" encoding="utf-8"?>
+<c:chartSpace xmlns:c="http://schemas.openxmlformats.org/drawingml/2006/chart" xmlns:r="http://schemas.openxmlformats.org/officeDocument/2006/relationships">
+  <c:lang val="en-US"/>
+  <c:chart>
+    <c:title>
+      <c:tx>
+        <c:rich>
+          <a:bodyPr xmlns:a="http://schemas.openxmlformats.org/drawingml/2006/main"/>
+          <a:lstStyle xmlns:a="http://schemas.openxmlformats.org/drawingml/2006/main"/>
+          <a:p xmlns:a="http://schemas.openxmlformats.org/drawingml/2006/main">
+            <a:r>
+              <a:rPr sz="1875" b="1">
+                <a:solidFill>
+                  <a:srgbClr val="18324F"/>
+                </a:solidFill>
+                <a:latin typeface="Liberation Sans"/>
+                <a:ea typeface="Liberation Sans"/>
+                <a:cs typeface="Liberation Sans"/>
+              </a:rPr>
+              <a:t>Tamamlanma oranı: gerçek ve plan</a:t>
+            </a:r>
+          </a:p>
+        </c:rich>
+      </c:tx>
+      <c:overlay val="0"/>
+      <c:txPr>
+        <a:bodyPr xmlns:a="http://schemas.openxmlformats.org/drawingml/2006/main" anchorCtr="1"/>
+        <a:lstStyle xmlns:a="http://schemas.openxmlformats.org/drawingml/2006/main"/>
+        <a:p xmlns:a="http://schemas.openxmlformats.org/drawingml/2006/main">
+          <a:pPr>
+            <a:defRPr sz="1875" b="1">
+              <a:solidFill>
+                <a:srgbClr val="18324F"/>
+              </a:solidFill>
+              <a:latin typeface="Liberation Sans"/>
+              <a:ea typeface="Liberation Sans"/>
+              <a:cs typeface="Liberation Sans"/>
+            </a:defRPr>
+          </a:pPr>
+        </a:p>
+      </c:txPr>
+    </c:title>
+    <c:plotArea>
+      <c:barChart>
+        <c:barDir val="bar"/>
+        <c:grouping val="clustered"/>
+        <c:varyColors val="0"/>
+        <c:ser>
+          <c:idx val="0"/>
+          <c:order val="0"/>
+          <c:tx>
+            <c:v>Gerçek (%)</c:v>
+          </c:tx>
+          <c:spPr>
+            <a:solidFill xmlns:a="http://schemas.openxmlformats.org/drawingml/2006/main">
+              <a:srgbClr val="2563EB"/>
+            </a:solidFill>
+          </c:spPr>
+          <c:cat>
+            <c:strRef>
+              <c:f>'Chart Data'!$A$2:$A$4</c:f>
+              <c:strCache>
+                <c:ptCount val="3"/>
+                <c:pt idx="0">
+                  <c:v>Üretim Hattı</c:v>
+                </c:pt>
+                <c:pt idx="1">
+                  <c:v>Müşteri Portalı</c:v>
+                </c:pt>
+                <c:pt idx="2">
+                  <c:v>Depo Otomasyonu</c:v>
+                </c:pt>
+              </c:strCache>
+            </c:strRef>
+          </c:cat>
+          <c:val>
+            <c:numRef>
+              <c:f>'Chart Data'!$B$2:$B$4</c:f>
+              <c:numCache>
+                <c:formatCode>0"%"</c:formatCode>
+                <c:ptCount val="3"/>
+                <c:pt idx="0">
+                  <c:v>30</c:v>
+                </c:pt>
+                <c:pt idx="1">
+                  <c:v>47.5</c:v>
+                </c:pt>
+                <c:pt idx="2">
+                  <c:v>52</c:v>
+                </c:pt>
+              </c:numCache>
+            </c:numRef>
+          </c:val>
+        </c:ser>
+        <c:ser>
+          <c:idx val="1"/>
+          <c:order val="1"/>
+          <c:tx>
+            <c:v>Plan (%)</c:v>
+          </c:tx>
+          <c:spPr>
+            <a:solidFill xmlns:a="http://schemas.openxmlformats.org/drawingml/2006/main">
+              <a:srgbClr val="B8D0EF"/>
+            </a:solidFill>
+          </c:spPr>
+          <c:cat>
+            <c:strRef>
+              <c:f>'Chart Data'!$C$2:$C$4</c:f>
+              <c:strCache>
+                <c:ptCount val="3"/>
+                <c:pt idx="0">
+                  <c:v>Üretim Hattı</c:v>
+                </c:pt>
+                <c:pt idx="1">
+                  <c:v>Müşteri Portalı</c:v>
+                </c:pt>
+                <c:pt idx="2">
+                  <c:v>Depo Otomasyonu</c:v>
+                </c:pt>
+              </c:strCache>
+            </c:strRef>
+          </c:cat>
+          <c:val>
+            <c:numRef>
+              <c:f>'Chart Data'!$D$2:$D$4</c:f>
+              <c:numCache>
+                <c:formatCode>0"%"</c:formatCode>
+                <c:ptCount val="3"/>
+                <c:pt idx="0">
+                  <c:v>57.6</c:v>
+                </c:pt>
+                <c:pt idx="1">
+                  <c:v>44.8</c:v>
+                </c:pt>
+                <c:pt idx="2">
+                  <c:v>63.8</c:v>
+                </c:pt>
+              </c:numCache>
+            </c:numRef>
+          </c:val>
+        </c:ser>
+        <c:dLbls>
+          <c:numFmt formatCode="0&quot;%&quot;" sourceLinked="0"/>
+          <c:txPr>
+            <a:bodyPr xmlns:a="http://schemas.openxmlformats.org/drawingml/2006/main" anchorCtr="1"/>
+            <a:lstStyle xmlns:a="http://schemas.openxmlformats.org/drawingml/2006/main"/>
+            <a:p xmlns:a="http://schemas.openxmlformats.org/drawingml/2006/main">
+              <a:pPr>
+                <a:defRPr sz="1650" b="1">
+                  <a:solidFill>
+                    <a:srgbClr val="26394D"/>
+                  </a:solidFill>
+                  <a:latin typeface="Liberation Sans"/>
+                  <a:ea typeface="Liberation Sans"/>
+                  <a:cs typeface="Liberation Sans"/>
+                </a:defRPr>
+              </a:pPr>
+            </a:p>
+          </c:txPr>
+          <c:dLblPos val="outEnd"/>
+          <c:showLegendKey val="0"/>
+          <c:showVal val="1"/>
+          <c:showCatName val="0"/>
+          <c:showSerName val="0"/>
+          <c:showPercent val="0"/>
+          <c:showBubbleSize val="0"/>
+          <c:showLeaderLines val="0"/>
+        </c:dLbls>
+        <c:gapWidth val="70"/>
+        <c:overlap val="0"/>
+        <c:axId val="48650112"/>
+        <c:axId val="48672768"/>
+      </c:barChart>
+      <c:catAx>
+        <c:axId val="48650112"/>
+        <c:scaling>
+          <c:orientation val="minMax"/>
+        </c:scaling>
+        <c:delete val="0"/>
+        <c:axPos val="l"/>
+        <c:numFmt formatCode="General"/>
+        <c:majorTickMark val="none"/>
+        <c:minorTickMark val="none"/>
+        <c:spPr>
+          <a:ln xmlns:a="http://schemas.openxmlformats.org/drawingml/2006/main" w="9525">
+            <a:solidFill>
+              <a:srgbClr val="DCE5EE"/>
+            </a:solidFill>
+          </a:ln>
+        </c:spPr>
+        <c:txPr>
+          <a:bodyPr xmlns:a="http://schemas.openxmlformats.org/drawingml/2006/main" anchorCtr="1"/>
+          <a:lstStyle xmlns:a="http://schemas.openxmlformats.org/drawingml/2006/main"/>
+          <a:p xmlns:a="http://schemas.openxmlformats.org/drawingml/2006/main">
+            <a:pPr>
+              <a:defRPr sz="1500">
+                <a:solidFill>
+                  <a:srgbClr val="26394D"/>
+                </a:solidFill>
+                <a:latin typeface="Liberation Sans"/>
+                <a:ea typeface="Liberation Sans"/>
+                <a:cs typeface="Liberation Sans"/>
+              </a:defRPr>
+            </a:pPr>
+          </a:p>
+        </c:txPr>
+        <c:crossAx val="48672768"/>
+      </c:catAx>
+      <c:valAx>
+        <c:axId val="48672768"/>
+        <c:scaling>
+          <c:orientation val="minMax"/>
+          <c:max val="100"/>
+          <c:min val="0"/>
+        </c:scaling>
+        <c:delete val="0"/>
+        <c:axPos val="b"/>
+        <c:majorGridlines>
+          <c:spPr>
+            <a:ln xmlns:a="http://schemas.openxmlformats.org/drawingml/2006/main" w="9525">
+              <a:solidFill>
+                <a:srgbClr val="DCE5EE"/>
+              </a:solidFill>
+              <a:prstDash val="solid"/>
+            </a:ln>
+          </c:spPr>
+        </c:majorGridlines>
+        <c:numFmt formatCode="0&quot;%&quot;"/>
+        <c:majorTickMark val="none"/>
+        <c:minorTickMark val="none"/>
+        <c:spPr>
+          <a:ln xmlns:a="http://schemas.openxmlformats.org/drawingml/2006/main" w="9525">
+            <a:solidFill>
+              <a:srgbClr val="D4D4D4"/>
+            </a:solidFill>
+            <a:prstDash val="solid"/>
+          </a:ln>
+        </c:spPr>
+        <c:txPr>
+          <a:bodyPr xmlns:a="http://schemas.openxmlformats.org/drawingml/2006/main" anchorCtr="1"/>
+          <a:lstStyle xmlns:a="http://schemas.openxmlformats.org/drawingml/2006/main"/>
+          <a:p xmlns:a="http://schemas.openxmlformats.org/drawingml/2006/main">
+            <a:pPr>
+              <a:defRPr sz="1350">
+                <a:solidFill>
+                  <a:srgbClr val="61758A"/>
+                </a:solidFill>
+                <a:latin typeface="Liberation Sans"/>
+                <a:ea typeface="Liberation Sans"/>
+                <a:cs typeface="Liberation Sans"/>
+              </a:defRPr>
+            </a:pPr>
+          </a:p>
+        </c:txPr>
+        <c:crossAx val="48650112"/>
+        <c:crossBetween val="between"/>
+        <c:majorUnit val="25"/>
+      </c:valAx>
+      <c:spPr>
+        <a:solidFill xmlns:a="http://schemas.openxmlformats.org/drawingml/2006/main">
+          <a:srgbClr val="FFFFFF"/>
+        </a:solidFill>
+      </c:spPr>
+    </c:plotArea>
+    <c:legend>
+      <c:legendPos val="r"/>
+      <c:overlay val="0"/>
+      <c:txPr>
+        <a:bodyPr xmlns:a="http://schemas.openxmlformats.org/drawingml/2006/main" anchorCtr="1"/>
+        <a:lstStyle xmlns:a="http://schemas.openxmlformats.org/drawingml/2006/main"/>
+        <a:p xmlns:a="http://schemas.openxmlformats.org/drawingml/2006/main">
+          <a:pPr>
+            <a:defRPr sz="1500">
+              <a:solidFill>
+                <a:srgbClr val="61758A"/>
+              </a:solidFill>
+              <a:latin typeface="Liberation Sans"/>
+              <a:ea typeface="Liberation Sans"/>
+              <a:cs typeface="Liberation Sans"/>
+            </a:defRPr>
+          </a:pPr>
+        </a:p>
+      </c:txPr>
+    </c:legend>
+    <c:plotVisOnly val="1"/>
+  </c:chart>
+  <c:spPr>
+    <a:solidFill xmlns:a="http://schemas.openxmlformats.org/drawingml/2006/main">
+      <a:srgbClr val="FFFFFF"/>
+    </a:solidFill>
+  </c:spPr>
+  <c:externalData r:id="rIdChartSnapshot1">
+    <c:autoUpdate val="0"/>
+  </c:externalData>
+</c:chartSpace>
+</file>
+
+<file path=ppt/slides/charts/chart2.xml><?xml version="1.0" encoding="utf-8"?>
+<c:chartSpace xmlns:c="http://schemas.openxmlformats.org/drawingml/2006/chart" xmlns:r="http://schemas.openxmlformats.org/officeDocument/2006/relationships">
+  <c:lang val="en-US"/>
+  <c:chart>
+    <c:title>
+      <c:tx>
+        <c:rich>
+          <a:bodyPr xmlns:a="http://schemas.openxmlformats.org/drawingml/2006/main"/>
+          <a:lstStyle xmlns:a="http://schemas.openxmlformats.org/drawingml/2006/main"/>
+          <a:p xmlns:a="http://schemas.openxmlformats.org/drawingml/2006/main">
+            <a:r>
+              <a:rPr sz="1725" b="1">
+                <a:solidFill>
+                  <a:srgbClr val="18324F"/>
+                </a:solidFill>
+                <a:latin typeface="Liberation Sans"/>
+                <a:ea typeface="Liberation Sans"/>
+                <a:cs typeface="Liberation Sans"/>
+              </a:rPr>
+              <a:t>Üretim: haftalık ilerleme</a:t>
+            </a:r>
+          </a:p>
+        </c:rich>
+      </c:tx>
+      <c:overlay val="0"/>
+      <c:txPr>
+        <a:bodyPr xmlns:a="http://schemas.openxmlformats.org/drawingml/2006/main" anchorCtr="1"/>
+        <a:lstStyle xmlns:a="http://schemas.openxmlformats.org/drawingml/2006/main"/>
+        <a:p xmlns:a="http://schemas.openxmlformats.org/drawingml/2006/main">
+          <a:pPr>
+            <a:defRPr sz="1725" b="1">
+              <a:solidFill>
+                <a:srgbClr val="18324F"/>
+              </a:solidFill>
+              <a:latin typeface="Liberation Sans"/>
+              <a:ea typeface="Liberation Sans"/>
+              <a:cs typeface="Liberation Sans"/>
+            </a:defRPr>
+          </a:pPr>
+        </a:p>
+      </c:txPr>
+    </c:title>
+    <c:plotArea>
+      <c:lineChart>
+        <c:grouping val="standard"/>
+        <c:varyColors val="0"/>
+        <c:ser>
+          <c:idx val="0"/>
+          <c:order val="0"/>
+          <c:tx>
+            <c:v>Üretim Hattı (%)</c:v>
+          </c:tx>
+          <c:spPr>
+            <a:ln xmlns:a="http://schemas.openxmlformats.org/drawingml/2006/main" w="28575">
+              <a:solidFill>
+                <a:srgbClr val="0D9488"/>
+              </a:solidFill>
+              <a:prstDash val="solid"/>
+            </a:ln>
+          </c:spPr>
+          <c:marker>
+            <c:symbol val="circle"/>
+            <c:size val="11"/>
+            <c:spPr>
+              <a:solidFill xmlns:a="http://schemas.openxmlformats.org/drawingml/2006/main">
+                <a:srgbClr val="0D9488"/>
+              </a:solidFill>
+            </c:spPr>
+          </c:marker>
+          <c:cat>
+            <c:strRef>
+              <c:f>'Chart Data'!$A$2:$A$2</c:f>
+              <c:strCache>
+                <c:ptCount val="1"/>
+                <c:pt idx="0">
+                  <c:v>1. Hafta</c:v>
+                </c:pt>
+              </c:strCache>
+            </c:strRef>
+          </c:cat>
+          <c:val>
+            <c:numRef>
+              <c:f>'Chart Data'!$B$2:$B$2</c:f>
+              <c:numCache>
+                <c:formatCode>0"%"</c:formatCode>
+                <c:ptCount val="1"/>
+                <c:pt idx="0">
+                  <c:v>30</c:v>
+                </c:pt>
+              </c:numCache>
+            </c:numRef>
+          </c:val>
+          <c:smooth val="0"/>
+        </c:ser>
+        <c:dLbls>
+          <c:numFmt formatCode="0&quot;%&quot;" sourceLinked="0"/>
+          <c:txPr>
+            <a:bodyPr xmlns:a="http://schemas.openxmlformats.org/drawingml/2006/main" anchorCtr="1"/>
+            <a:lstStyle xmlns:a="http://schemas.openxmlformats.org/drawingml/2006/main"/>
+            <a:p xmlns:a="http://schemas.openxmlformats.org/drawingml/2006/main">
+              <a:pPr>
+                <a:defRPr sz="1875" b="1">
+                  <a:solidFill>
+                    <a:srgbClr val="0D9488"/>
+                  </a:solidFill>
+                  <a:latin typeface="Liberation Sans"/>
+                  <a:ea typeface="Liberation Sans"/>
+                  <a:cs typeface="Liberation Sans"/>
+                </a:defRPr>
+              </a:pPr>
+            </a:p>
+          </c:txPr>
+          <c:showLegendKey val="0"/>
+          <c:showVal val="1"/>
+          <c:showCatName val="0"/>
+          <c:showSerName val="0"/>
+          <c:showPercent val="0"/>
+          <c:showBubbleSize val="0"/>
+          <c:showLeaderLines val="0"/>
+        </c:dLbls>
+        <c:smooth val="0"/>
+        <c:axId val="48650112"/>
+        <c:axId val="48672768"/>
+      </c:lineChart>
+      <c:catAx>
+        <c:axId val="48650112"/>
+        <c:scaling>
+          <c:orientation val="minMax"/>
+        </c:scaling>
+        <c:delete val="0"/>
+        <c:axPos val="b"/>
+        <c:numFmt formatCode="General"/>
+        <c:majorTickMark val="none"/>
+        <c:minorTickMark val="none"/>
+        <c:spPr>
+          <a:ln xmlns:a="http://schemas.openxmlformats.org/drawingml/2006/main" w="9525">
+            <a:solidFill>
+              <a:srgbClr val="DCE5EE"/>
+            </a:solidFill>
+          </a:ln>
+        </c:spPr>
+        <c:txPr>
+          <a:bodyPr xmlns:a="http://schemas.openxmlformats.org/drawingml/2006/main" anchorCtr="1"/>
+          <a:lstStyle xmlns:a="http://schemas.openxmlformats.org/drawingml/2006/main"/>
+          <a:p xmlns:a="http://schemas.openxmlformats.org/drawingml/2006/main">
+            <a:pPr>
+              <a:defRPr sz="1350">
+                <a:solidFill>
+                  <a:srgbClr val="61758A"/>
+                </a:solidFill>
+                <a:latin typeface="Liberation Sans"/>
+                <a:ea typeface="Liberation Sans"/>
+                <a:cs typeface="Liberation Sans"/>
+              </a:defRPr>
+            </a:pPr>
+          </a:p>
+        </c:txPr>
+        <c:crossAx val="48672768"/>
+      </c:catAx>
+      <c:valAx>
+        <c:axId val="48672768"/>
+        <c:scaling>
+          <c:orientation val="minMax"/>
+          <c:max val="100"/>
+          <c:min val="0"/>
+        </c:scaling>
+        <c:delete val="0"/>
+        <c:axPos val="l"/>
+        <c:majorGridlines>
+          <c:spPr>
+            <a:ln xmlns:a="http://schemas.openxmlformats.org/drawingml/2006/main" w="9525">
+              <a:solidFill>
+                <a:srgbClr val="DCE5EE"/>
+              </a:solidFill>
+              <a:prstDash val="solid"/>
+            </a:ln>
+          </c:spPr>
+        </c:majorGridlines>
+        <c:numFmt formatCode="0&quot;%&quot;"/>
+        <c:majorTickMark val="none"/>
+        <c:minorTickMark val="none"/>
+        <c:spPr>
+          <a:ln xmlns:a="http://schemas.openxmlformats.org/drawingml/2006/main" w="9525">
+            <a:solidFill>
+              <a:srgbClr val="D4D4D4"/>
+            </a:solidFill>
+            <a:prstDash val="solid"/>
+          </a:ln>
+        </c:spPr>
+        <c:txPr>
+          <a:bodyPr xmlns:a="http://schemas.openxmlformats.org/drawingml/2006/main" anchorCtr="1"/>
+          <a:lstStyle xmlns:a="http://schemas.openxmlformats.org/drawingml/2006/main"/>
+          <a:p xmlns:a="http://schemas.openxmlformats.org/drawingml/2006/main">
+            <a:pPr>
+              <a:defRPr sz="1350">
+                <a:solidFill>
+                  <a:srgbClr val="61758A"/>
+                </a:solidFill>
+                <a:latin typeface="Liberation Sans"/>
+                <a:ea typeface="Liberation Sans"/>
+                <a:cs typeface="Liberation Sans"/>
+              </a:defRPr>
+            </a:pPr>
+          </a:p>
+        </c:txPr>
+        <c:crossAx val="48650112"/>
+        <c:crossBetween val="between"/>
+        <c:majorUnit val="25"/>
+      </c:valAx>
+      <c:spPr>
+        <a:solidFill xmlns:a="http://schemas.openxmlformats.org/drawingml/2006/main">
+          <a:srgbClr val="FFFFFF"/>
+        </a:solidFill>
+      </c:spPr>
+    </c:plotArea>
+    <c:plotVisOnly val="1"/>
+    <c:dispBlanksAs val="gap"/>
+  </c:chart>
+  <c:spPr>
+    <a:solidFill xmlns:a="http://schemas.openxmlformats.org/drawingml/2006/main">
+      <a:srgbClr val="FFFFFF"/>
+    </a:solidFill>
+  </c:spPr>
+  <c:externalData r:id="rIdChartSnapshot1">
+    <c:autoUpdate val="0"/>
+  </c:externalData>
+</c:chartSpace>
+</file>
+
 <file path=ppt/slides/slide1.xml><?xml version="1.0" encoding="utf-8"?>
 <p:sld xmlns:p="http://schemas.openxmlformats.org/presentationml/2006/main">
   <p:cSld>
@@ -2833,6 +3459,7 @@
           </a:lstStyle>
           <a:p xmlns:a="http://schemas.openxmlformats.org/drawingml/2006/main">
             <a:pPr algn="l">
+              <a:buNone/>
               <a:defRPr sz="3225" b="1">
                 <a:solidFill>
                   <a:srgbClr val="18324F"/>
@@ -2902,6 +3529,7 @@
           </a:lstStyle>
           <a:p xmlns:a="http://schemas.openxmlformats.org/drawingml/2006/main">
             <a:pPr algn="l">
+              <a:buNone/>
               <a:defRPr sz="1875" b="0">
                 <a:solidFill>
                   <a:srgbClr val="61758A"/>
@@ -2971,6 +3599,7 @@
           </a:lstStyle>
           <a:p xmlns:a="http://schemas.openxmlformats.org/drawingml/2006/main">
             <a:pPr algn="l">
+              <a:buNone/>
               <a:defRPr sz="1725" b="0">
                 <a:solidFill>
                   <a:srgbClr val="61758A"/>
@@ -2994,81 +3623,12 @@
           </a:p>
         </p:txBody>
       </p:sp>
-      <p:sp>
-        <p:nvSpPr>
-          <p:cNvPr id="4" name="portfolio-summary">
-            <a:extLst xmlns:a="http://schemas.openxmlformats.org/drawingml/2006/main">
-              <a:ext uri="{FF2B5EF4-FFF2-40B4-BE49-F238E27FC236}">
-                <a16:creationId xmlns:a16="http://schemas.microsoft.com/office/drawing/2014/main" id="{EB57EBBB-44C7-4A10-9121-25C786733D0E}"/>
-              </a:ext>
-            </a:extLst>
-          </p:cNvPr>
-          <p:cNvSpPr>
-            <a:spLocks xmlns:a="http://schemas.openxmlformats.org/drawingml/2006/main" noGrp="1"/>
-          </p:cNvSpPr>
-          <p:nvPr/>
-        </p:nvSpPr>
-        <p:spPr>
-          <a:xfrm xmlns:a="http://schemas.openxmlformats.org/drawingml/2006/main">
-            <a:off x="457200" y="1428750"/>
-            <a:ext cx="14325600" cy="361950"/>
-          </a:xfrm>
-          <a:prstGeom xmlns:a="http://schemas.openxmlformats.org/drawingml/2006/main" prst="rect">
-            <a:avLst/>
-          </a:prstGeom>
-          <a:noFill xmlns:a="http://schemas.openxmlformats.org/drawingml/2006/main"/>
-          <a:ln xmlns:a="http://schemas.openxmlformats.org/drawingml/2006/main" w="0">
-            <a:noFill/>
-            <a:prstDash val="solid"/>
-          </a:ln>
-        </p:spPr>
-        <p:txBody>
-          <a:bodyPr xmlns:a="http://schemas.openxmlformats.org/drawingml/2006/main" wrap="square" lIns="0" tIns="0" rIns="0" bIns="0" anchor="ctr">
-            <a:noAutofit/>
-          </a:bodyPr>
-          <a:lstStyle xmlns:a="http://schemas.openxmlformats.org/drawingml/2006/main">
-            <a:defPPr algn="l">
-              <a:defRPr sz="2025" b="1">
-                <a:solidFill>
-                  <a:srgbClr val="2563EB"/>
-                </a:solidFill>
-                <a:latin typeface="Liberation Sans"/>
-                <a:ea typeface="Liberation Sans"/>
-                <a:cs typeface="Liberation Sans"/>
-              </a:defRPr>
-            </a:defPPr>
-          </a:lstStyle>
-          <a:p xmlns:a="http://schemas.openxmlformats.org/drawingml/2006/main">
-            <a:pPr algn="l">
-              <a:defRPr sz="2025" b="1">
-                <a:solidFill>
-                  <a:srgbClr val="2563EB"/>
-                </a:solidFill>
-                <a:latin typeface="Liberation Sans"/>
-                <a:ea typeface="Liberation Sans"/>
-                <a:cs typeface="Liberation Sans"/>
-              </a:defRPr>
-            </a:pPr>
-            <a:r>
-              <a:rPr sz="2025" b="1">
-                <a:solidFill>
-                  <a:srgbClr val="2563EB"/>
-                </a:solidFill>
-                <a:latin typeface="Liberation Sans"/>
-                <a:ea typeface="Liberation Sans"/>
-                <a:cs typeface="Liberation Sans"/>
-              </a:rPr>
-              <a:t>3 proje     2 projede takvim gecikmesi     1 projede bütçe aşımı</a:t>
-            </a:r>
-          </a:p>
-        </p:txBody>
-      </p:sp>
       <p:graphicFrame>
         <p:nvGraphicFramePr>
           <p:cNvPr id="5" name="">
             <a:extLst xmlns:a="http://schemas.openxmlformats.org/drawingml/2006/main">
               <a:ext uri="{FF2B5EF4-FFF2-40B4-BE49-F238E27FC236}">
-                <a16:creationId xmlns:a16="http://schemas.microsoft.com/office/drawing/2014/main" id="{C1C52A30-9603-4391-868C-B76E8FAFBC61}"/>
+                <a16:creationId xmlns:a16="http://schemas.microsoft.com/office/drawing/2014/main" id="{7C7AAB2F-39CF-4A26-B230-80F435EB0952}"/>
               </a:ext>
             </a:extLst>
           </p:cNvPr>
@@ -3076,8 +3636,8 @@
           <p:nvPr/>
         </p:nvGraphicFramePr>
         <p:xfrm>
-          <a:off xmlns:a="http://schemas.openxmlformats.org/drawingml/2006/main" x="457200" y="1866900"/>
-          <a:ext xmlns:a="http://schemas.openxmlformats.org/drawingml/2006/main" cx="14325600" cy="3924300"/>
+          <a:off xmlns:a="http://schemas.openxmlformats.org/drawingml/2006/main" x="457200" y="3524250"/>
+          <a:ext xmlns:a="http://schemas.openxmlformats.org/drawingml/2006/main" cx="14325600" cy="2628900"/>
         </p:xfrm>
         <a:graphic xmlns:a="http://schemas.openxmlformats.org/drawingml/2006/main">
           <a:graphicData uri="http://schemas.openxmlformats.org/drawingml/2006/table">
@@ -3091,15 +3651,17 @@
                 <a:gridCol w="3714750"/>
                 <a:gridCol w="2228850"/>
               </a:tblGrid>
-              <a:tr h="609600">
-                <a:tc>
-                  <a:txBody>
-                    <a:bodyPr wrap="square" anchor="ctr">
-                      <a:noAutofit/>
-                    </a:bodyPr>
-                    <a:lstStyle/>
-                    <a:p>
-                      <a:pPr algn="l"/>
+              <a:tr h="571500">
+                <a:tc>
+                  <a:txBody>
+                    <a:bodyPr wrap="square" anchor="ctr">
+                      <a:noAutofit/>
+                    </a:bodyPr>
+                    <a:lstStyle/>
+                    <a:p>
+                      <a:pPr algn="l">
+                        <a:buNone/>
+                      </a:pPr>
                       <a:r>
                         <a:rPr sz="1650" b="1">
                           <a:solidFill>
@@ -3113,7 +3675,7 @@
                       </a:r>
                     </a:p>
                   </a:txBody>
-                  <a:tcPr marL="133350" marR="114300" marT="57150" marB="57150" anchor="ctr">
+                  <a:tcPr marL="114300" marR="95250" marT="47625" marB="47625" anchor="ctr">
                     <a:solidFill>
                       <a:srgbClr val="18324F"/>
                     </a:solidFill>
@@ -3126,7 +3688,9 @@
                     </a:bodyPr>
                     <a:lstStyle/>
                     <a:p>
-                      <a:pPr algn="l"/>
+                      <a:pPr algn="l">
+                        <a:buNone/>
+                      </a:pPr>
                       <a:r>
                         <a:rPr sz="1650" b="1">
                           <a:solidFill>
@@ -3140,7 +3704,9 @@
                       </a:r>
                     </a:p>
                     <a:p>
-                      <a:pPr algn="l"/>
+                      <a:pPr algn="l">
+                        <a:buNone/>
+                      </a:pPr>
                       <a:r>
                         <a:rPr sz="1650" b="1">
                           <a:solidFill>
@@ -3154,7 +3720,7 @@
                       </a:r>
                     </a:p>
                   </a:txBody>
-                  <a:tcPr marL="133350" marR="114300" marT="57150" marB="57150" anchor="ctr">
+                  <a:tcPr marL="114300" marR="95250" marT="47625" marB="47625" anchor="ctr">
                     <a:solidFill>
                       <a:srgbClr val="18324F"/>
                     </a:solidFill>
@@ -3167,7 +3733,9 @@
                     </a:bodyPr>
                     <a:lstStyle/>
                     <a:p>
-                      <a:pPr algn="l"/>
+                      <a:pPr algn="l">
+                        <a:buNone/>
+                      </a:pPr>
                       <a:r>
                         <a:rPr sz="1650" b="1">
                           <a:solidFill>
@@ -3181,7 +3749,9 @@
                       </a:r>
                     </a:p>
                     <a:p>
-                      <a:pPr algn="l"/>
+                      <a:pPr algn="l">
+                        <a:buNone/>
+                      </a:pPr>
                       <a:r>
                         <a:rPr sz="1650" b="1">
                           <a:solidFill>
@@ -3195,7 +3765,7 @@
                       </a:r>
                     </a:p>
                   </a:txBody>
-                  <a:tcPr marL="133350" marR="114300" marT="57150" marB="57150" anchor="ctr">
+                  <a:tcPr marL="114300" marR="95250" marT="47625" marB="47625" anchor="ctr">
                     <a:solidFill>
                       <a:srgbClr val="18324F"/>
                     </a:solidFill>
@@ -3208,7 +3778,9 @@
                     </a:bodyPr>
                     <a:lstStyle/>
                     <a:p>
-                      <a:pPr algn="l"/>
+                      <a:pPr algn="l">
+                        <a:buNone/>
+                      </a:pPr>
                       <a:r>
                         <a:rPr sz="1650" b="1">
                           <a:solidFill>
@@ -3222,7 +3794,9 @@
                       </a:r>
                     </a:p>
                     <a:p>
-                      <a:pPr algn="l"/>
+                      <a:pPr algn="l">
+                        <a:buNone/>
+                      </a:pPr>
                       <a:r>
                         <a:rPr sz="1650" b="1">
                           <a:solidFill>
@@ -3236,7 +3810,7 @@
                       </a:r>
                     </a:p>
                   </a:txBody>
-                  <a:tcPr marL="133350" marR="114300" marT="57150" marB="57150" anchor="ctr">
+                  <a:tcPr marL="114300" marR="95250" marT="47625" marB="47625" anchor="ctr">
                     <a:solidFill>
                       <a:srgbClr val="18324F"/>
                     </a:solidFill>
@@ -3249,7 +3823,9 @@
                     </a:bodyPr>
                     <a:lstStyle/>
                     <a:p>
-                      <a:pPr algn="l"/>
+                      <a:pPr algn="l">
+                        <a:buNone/>
+                      </a:pPr>
                       <a:r>
                         <a:rPr sz="1650" b="1">
                           <a:solidFill>
@@ -3263,7 +3839,9 @@
                       </a:r>
                     </a:p>
                     <a:p>
-                      <a:pPr algn="l"/>
+                      <a:pPr algn="l">
+                        <a:buNone/>
+                      </a:pPr>
                       <a:r>
                         <a:rPr sz="1650" b="1">
                           <a:solidFill>
@@ -3277,7 +3855,7 @@
                       </a:r>
                     </a:p>
                   </a:txBody>
-                  <a:tcPr marL="133350" marR="114300" marT="57150" marB="57150" anchor="ctr">
+                  <a:tcPr marL="114300" marR="95250" marT="47625" marB="47625" anchor="ctr">
                     <a:solidFill>
                       <a:srgbClr val="18324F"/>
                     </a:solidFill>
@@ -3290,7 +3868,9 @@
                     </a:bodyPr>
                     <a:lstStyle/>
                     <a:p>
-                      <a:pPr algn="l"/>
+                      <a:pPr algn="l">
+                        <a:buNone/>
+                      </a:pPr>
                       <a:r>
                         <a:rPr sz="1650" b="1">
                           <a:solidFill>
@@ -3304,22 +3884,24 @@
                       </a:r>
                     </a:p>
                   </a:txBody>
-                  <a:tcPr marL="133350" marR="114300" marT="57150" marB="57150" anchor="ctr">
+                  <a:tcPr marL="114300" marR="95250" marT="47625" marB="47625" anchor="ctr">
                     <a:solidFill>
                       <a:srgbClr val="18324F"/>
                     </a:solidFill>
                   </a:tcPr>
                 </a:tc>
               </a:tr>
-              <a:tr h="1104900">
-                <a:tc>
-                  <a:txBody>
-                    <a:bodyPr wrap="square" anchor="ctr">
-                      <a:noAutofit/>
-                    </a:bodyPr>
-                    <a:lstStyle/>
-                    <a:p>
-                      <a:pPr algn="l"/>
+              <a:tr h="685800">
+                <a:tc>
+                  <a:txBody>
+                    <a:bodyPr wrap="square" anchor="ctr">
+                      <a:noAutofit/>
+                    </a:bodyPr>
+                    <a:lstStyle/>
+                    <a:p>
+                      <a:pPr algn="l">
+                        <a:buNone/>
+                      </a:pPr>
                       <a:r>
                         <a:rPr sz="1875" b="1">
                           <a:solidFill>
@@ -3333,7 +3915,9 @@
                       </a:r>
                     </a:p>
                     <a:p>
-                      <a:pPr algn="l"/>
+                      <a:pPr algn="l">
+                        <a:buNone/>
+                      </a:pPr>
                       <a:r>
                         <a:rPr sz="1875" b="1">
                           <a:solidFill>
@@ -3347,7 +3931,7 @@
                       </a:r>
                     </a:p>
                   </a:txBody>
-                  <a:tcPr marL="133350" marR="114300" marT="95250" marB="95250" anchor="ctr">
+                  <a:tcPr marL="114300" marR="95250" marT="47625" marB="47625" anchor="ctr">
                     <a:solidFill>
                       <a:srgbClr val="FFFFFF"/>
                     </a:solidFill>
@@ -3360,7 +3944,9 @@
                     </a:bodyPr>
                     <a:lstStyle/>
                     <a:p>
-                      <a:pPr algn="l"/>
+                      <a:pPr algn="l">
+                        <a:buNone/>
+                      </a:pPr>
                       <a:r>
                         <a:rPr sz="1875" b="0">
                           <a:solidFill>
@@ -3370,11 +3956,13 @@
                           <a:ea typeface="Liberation Sans"/>
                           <a:cs typeface="Liberation Sans"/>
                         </a:rPr>
-                        <a:t>50,5%</a:t>
-                      </a:r>
-                    </a:p>
-                    <a:p>
-                      <a:pPr algn="l"/>
+                        <a:t>30,0%</a:t>
+                      </a:r>
+                    </a:p>
+                    <a:p>
+                      <a:pPr algn="l">
+                        <a:buNone/>
+                      </a:pPr>
                       <a:r>
                         <a:rPr sz="1875" b="0">
                           <a:solidFill>
@@ -3388,7 +3976,7 @@
                       </a:r>
                     </a:p>
                   </a:txBody>
-                  <a:tcPr marL="133350" marR="114300" marT="95250" marB="95250" anchor="ctr">
+                  <a:tcPr marL="114300" marR="95250" marT="47625" marB="47625" anchor="ctr">
                     <a:solidFill>
                       <a:srgbClr val="FFFFFF"/>
                     </a:solidFill>
@@ -3401,7 +3989,9 @@
                     </a:bodyPr>
                     <a:lstStyle/>
                     <a:p>
-                      <a:pPr algn="l"/>
+                      <a:pPr algn="l">
+                        <a:buNone/>
+                      </a:pPr>
                       <a:r>
                         <a:rPr sz="1875" b="0">
                           <a:solidFill>
@@ -3415,7 +4005,9 @@
                       </a:r>
                     </a:p>
                     <a:p>
-                      <a:pPr algn="l"/>
+                      <a:pPr algn="l">
+                        <a:buNone/>
+                      </a:pPr>
                       <a:r>
                         <a:rPr sz="1875" b="0">
                           <a:solidFill>
@@ -3425,11 +4017,26 @@
                           <a:ea typeface="Liberation Sans"/>
                           <a:cs typeface="Liberation Sans"/>
                         </a:rPr>
-                        <a:t>Güncel 11.12</a:t>
-                      </a:r>
-                    </a:p>
-                    <a:p>
-                      <a:pPr algn="l"/>
+                        <a:t>11.12 (+7 gün)</a:t>
+                      </a:r>
+                    </a:p>
+                  </a:txBody>
+                  <a:tcPr marL="114300" marR="95250" marT="47625" marB="47625" anchor="ctr">
+                    <a:solidFill>
+                      <a:srgbClr val="FFFFFF"/>
+                    </a:solidFill>
+                  </a:tcPr>
+                </a:tc>
+                <a:tc>
+                  <a:txBody>
+                    <a:bodyPr wrap="square" anchor="ctr">
+                      <a:noAutofit/>
+                    </a:bodyPr>
+                    <a:lstStyle/>
+                    <a:p>
+                      <a:pPr algn="l">
+                        <a:buNone/>
+                      </a:pPr>
                       <a:r>
                         <a:rPr sz="1875" b="0">
                           <a:solidFill>
@@ -3439,11 +4046,27 @@
                           <a:ea typeface="Liberation Sans"/>
                           <a:cs typeface="Liberation Sans"/>
                         </a:rPr>
-                        <a:t>+7 gün</a:t>
-                      </a:r>
-                    </a:p>
-                  </a:txBody>
-                  <a:tcPr marL="133350" marR="114300" marT="95250" marB="95250" anchor="ctr">
+                        <a:t>5 kişi</a:t>
+                      </a:r>
+                    </a:p>
+                    <a:p>
+                      <a:pPr algn="l">
+                        <a:buNone/>
+                      </a:pPr>
+                      <a:r>
+                        <a:rPr sz="1875" b="0">
+                          <a:solidFill>
+                            <a:srgbClr val="26394D"/>
+                          </a:solidFill>
+                          <a:latin typeface="Liberation Sans"/>
+                          <a:ea typeface="Liberation Sans"/>
+                          <a:cs typeface="Liberation Sans"/>
+                        </a:rPr>
+                        <a:t>648 saat</a:t>
+                      </a:r>
+                    </a:p>
+                  </a:txBody>
+                  <a:tcPr marL="114300" marR="95250" marT="47625" marB="47625" anchor="ctr">
                     <a:solidFill>
                       <a:srgbClr val="FFFFFF"/>
                     </a:solidFill>
@@ -3456,7 +4079,9 @@
                     </a:bodyPr>
                     <a:lstStyle/>
                     <a:p>
-                      <a:pPr algn="l"/>
+                      <a:pPr algn="l">
+                        <a:buNone/>
+                      </a:pPr>
                       <a:r>
                         <a:rPr sz="1875" b="0">
                           <a:solidFill>
@@ -3466,11 +4091,13 @@
                           <a:ea typeface="Liberation Sans"/>
                           <a:cs typeface="Liberation Sans"/>
                         </a:rPr>
-                        <a:t>5 kişi</a:t>
-                      </a:r>
-                    </a:p>
-                    <a:p>
-                      <a:pPr algn="l"/>
+                        <a:t>Müh. 110 / Ürt. 127 / SA 144</a:t>
+                      </a:r>
+                    </a:p>
+                    <a:p>
+                      <a:pPr algn="l">
+                        <a:buNone/>
+                      </a:pPr>
                       <a:r>
                         <a:rPr sz="1875" b="0">
                           <a:solidFill>
@@ -3480,11 +4107,11 @@
                           <a:ea typeface="Liberation Sans"/>
                           <a:cs typeface="Liberation Sans"/>
                         </a:rPr>
-                        <a:t>648 saat</a:t>
-                      </a:r>
-                    </a:p>
-                  </a:txBody>
-                  <a:tcPr marL="133350" marR="114300" marT="95250" marB="95250" anchor="ctr">
+                        <a:t>Klt. 155 / PY 112</a:t>
+                      </a:r>
+                    </a:p>
+                  </a:txBody>
+                  <a:tcPr marL="114300" marR="95250" marT="47625" marB="47625" anchor="ctr">
                     <a:solidFill>
                       <a:srgbClr val="FFFFFF"/>
                     </a:solidFill>
@@ -3497,7 +4124,85 @@
                     </a:bodyPr>
                     <a:lstStyle/>
                     <a:p>
-                      <a:pPr algn="l"/>
+                      <a:pPr algn="l">
+                        <a:buNone/>
+                      </a:pPr>
+                      <a:r>
+                        <a:rPr sz="1950" b="1">
+                          <a:solidFill>
+                            <a:srgbClr val="C23C4B"/>
+                          </a:solidFill>
+                          <a:latin typeface="Liberation Sans"/>
+                          <a:ea typeface="Liberation Sans"/>
+                          <a:cs typeface="Liberation Sans"/>
+                        </a:rPr>
+                        <a:t>Yüksek</a:t>
+                      </a:r>
+                    </a:p>
+                  </a:txBody>
+                  <a:tcPr marL="114300" marR="95250" marT="47625" marB="47625" anchor="ctr">
+                    <a:solidFill>
+                      <a:srgbClr val="FCE8EC"/>
+                    </a:solidFill>
+                  </a:tcPr>
+                </a:tc>
+              </a:tr>
+              <a:tr h="685800">
+                <a:tc>
+                  <a:txBody>
+                    <a:bodyPr wrap="square" anchor="ctr">
+                      <a:noAutofit/>
+                    </a:bodyPr>
+                    <a:lstStyle/>
+                    <a:p>
+                      <a:pPr algn="l">
+                        <a:buNone/>
+                      </a:pPr>
+                      <a:r>
+                        <a:rPr sz="1875" b="1">
+                          <a:solidFill>
+                            <a:srgbClr val="26394D"/>
+                          </a:solidFill>
+                          <a:latin typeface="Liberation Sans"/>
+                          <a:ea typeface="Liberation Sans"/>
+                          <a:cs typeface="Liberation Sans"/>
+                        </a:rPr>
+                        <a:t>Müşteri Portalı</a:t>
+                      </a:r>
+                    </a:p>
+                    <a:p>
+                      <a:pPr algn="l">
+                        <a:buNone/>
+                      </a:pPr>
+                      <a:r>
+                        <a:rPr sz="1875" b="1">
+                          <a:solidFill>
+                            <a:srgbClr val="26394D"/>
+                          </a:solidFill>
+                          <a:latin typeface="Liberation Sans"/>
+                          <a:ea typeface="Liberation Sans"/>
+                          <a:cs typeface="Liberation Sans"/>
+                        </a:rPr>
+                        <a:t>Geliştirme</a:t>
+                      </a:r>
+                    </a:p>
+                  </a:txBody>
+                  <a:tcPr marL="114300" marR="95250" marT="47625" marB="47625" anchor="ctr">
+                    <a:solidFill>
+                      <a:srgbClr val="F2F6FB"/>
+                    </a:solidFill>
+                  </a:tcPr>
+                </a:tc>
+                <a:tc>
+                  <a:txBody>
+                    <a:bodyPr wrap="square" anchor="ctr">
+                      <a:noAutofit/>
+                    </a:bodyPr>
+                    <a:lstStyle/>
+                    <a:p>
+                      <a:pPr algn="l">
+                        <a:buNone/>
+                      </a:pPr>
                       <a:r>
                         <a:rPr sz="1875" b="0">
                           <a:solidFill>
@@ -3507,11 +4212,13 @@
                           <a:ea typeface="Liberation Sans"/>
                           <a:cs typeface="Liberation Sans"/>
                         </a:rPr>
-                        <a:t>Müh. 110 / Ürt. 127</a:t>
-                      </a:r>
-                    </a:p>
-                    <a:p>
-                      <a:pPr algn="l"/>
+                        <a:t>47,5%</a:t>
+                      </a:r>
+                    </a:p>
+                    <a:p>
+                      <a:pPr algn="l">
+                        <a:buNone/>
+                      </a:pPr>
                       <a:r>
                         <a:rPr sz="1875" b="0">
                           <a:solidFill>
@@ -3521,11 +4228,26 @@
                           <a:ea typeface="Liberation Sans"/>
                           <a:cs typeface="Liberation Sans"/>
                         </a:rPr>
-                        <a:t>SA 144 / Klt. 155</a:t>
-                      </a:r>
-                    </a:p>
-                    <a:p>
-                      <a:pPr algn="l"/>
+                        <a:t>Plan 44,8%</a:t>
+                      </a:r>
+                    </a:p>
+                  </a:txBody>
+                  <a:tcPr marL="114300" marR="95250" marT="47625" marB="47625" anchor="ctr">
+                    <a:solidFill>
+                      <a:srgbClr val="F2F6FB"/>
+                    </a:solidFill>
+                  </a:tcPr>
+                </a:tc>
+                <a:tc>
+                  <a:txBody>
+                    <a:bodyPr wrap="square" anchor="ctr">
+                      <a:noAutofit/>
+                    </a:bodyPr>
+                    <a:lstStyle/>
+                    <a:p>
+                      <a:pPr algn="l">
+                        <a:buNone/>
+                      </a:pPr>
                       <a:r>
                         <a:rPr sz="1875" b="0">
                           <a:solidFill>
@@ -3535,11 +4257,177 @@
                           <a:ea typeface="Liberation Sans"/>
                           <a:cs typeface="Liberation Sans"/>
                         </a:rPr>
-                        <a:t>PY 112</a:t>
-                      </a:r>
-                    </a:p>
-                  </a:txBody>
-                  <a:tcPr marL="133350" marR="114300" marT="95250" marB="95250" anchor="ctr">
+                        <a:t>Plan 27.11</a:t>
+                      </a:r>
+                    </a:p>
+                    <a:p>
+                      <a:pPr algn="l">
+                        <a:buNone/>
+                      </a:pPr>
+                      <a:r>
+                        <a:rPr sz="1875" b="0">
+                          <a:solidFill>
+                            <a:srgbClr val="26394D"/>
+                          </a:solidFill>
+                          <a:latin typeface="Liberation Sans"/>
+                          <a:ea typeface="Liberation Sans"/>
+                          <a:cs typeface="Liberation Sans"/>
+                        </a:rPr>
+                        <a:t>27.11 (planında)</a:t>
+                      </a:r>
+                    </a:p>
+                  </a:txBody>
+                  <a:tcPr marL="114300" marR="95250" marT="47625" marB="47625" anchor="ctr">
+                    <a:solidFill>
+                      <a:srgbClr val="F2F6FB"/>
+                    </a:solidFill>
+                  </a:tcPr>
+                </a:tc>
+                <a:tc>
+                  <a:txBody>
+                    <a:bodyPr wrap="square" anchor="ctr">
+                      <a:noAutofit/>
+                    </a:bodyPr>
+                    <a:lstStyle/>
+                    <a:p>
+                      <a:pPr algn="l">
+                        <a:buNone/>
+                      </a:pPr>
+                      <a:r>
+                        <a:rPr sz="1875" b="0">
+                          <a:solidFill>
+                            <a:srgbClr val="26394D"/>
+                          </a:solidFill>
+                          <a:latin typeface="Liberation Sans"/>
+                          <a:ea typeface="Liberation Sans"/>
+                          <a:cs typeface="Liberation Sans"/>
+                        </a:rPr>
+                        <a:t>4 kişi</a:t>
+                      </a:r>
+                    </a:p>
+                    <a:p>
+                      <a:pPr algn="l">
+                        <a:buNone/>
+                      </a:pPr>
+                      <a:r>
+                        <a:rPr sz="1875" b="0">
+                          <a:solidFill>
+                            <a:srgbClr val="26394D"/>
+                          </a:solidFill>
+                          <a:latin typeface="Liberation Sans"/>
+                          <a:ea typeface="Liberation Sans"/>
+                          <a:cs typeface="Liberation Sans"/>
+                        </a:rPr>
+                        <a:t>536 saat</a:t>
+                      </a:r>
+                    </a:p>
+                  </a:txBody>
+                  <a:tcPr marL="114300" marR="95250" marT="47625" marB="47625" anchor="ctr">
+                    <a:solidFill>
+                      <a:srgbClr val="F2F6FB"/>
+                    </a:solidFill>
+                  </a:tcPr>
+                </a:tc>
+                <a:tc>
+                  <a:txBody>
+                    <a:bodyPr wrap="square" anchor="ctr">
+                      <a:noAutofit/>
+                    </a:bodyPr>
+                    <a:lstStyle/>
+                    <a:p>
+                      <a:pPr algn="l">
+                        <a:buNone/>
+                      </a:pPr>
+                      <a:r>
+                        <a:rPr sz="1875" b="0">
+                          <a:solidFill>
+                            <a:srgbClr val="26394D"/>
+                          </a:solidFill>
+                          <a:latin typeface="Liberation Sans"/>
+                          <a:ea typeface="Liberation Sans"/>
+                          <a:cs typeface="Liberation Sans"/>
+                        </a:rPr>
+                        <a:t>BT 269 / Klt. 155 / PY 112</a:t>
+                      </a:r>
+                    </a:p>
+                  </a:txBody>
+                  <a:tcPr marL="114300" marR="95250" marT="47625" marB="47625" anchor="ctr">
+                    <a:solidFill>
+                      <a:srgbClr val="F2F6FB"/>
+                    </a:solidFill>
+                  </a:tcPr>
+                </a:tc>
+                <a:tc>
+                  <a:txBody>
+                    <a:bodyPr wrap="square" anchor="ctr">
+                      <a:noAutofit/>
+                    </a:bodyPr>
+                    <a:lstStyle/>
+                    <a:p>
+                      <a:pPr algn="l">
+                        <a:buNone/>
+                      </a:pPr>
+                      <a:r>
+                        <a:rPr sz="1950" b="1">
+                          <a:solidFill>
+                            <a:srgbClr val="D97706"/>
+                          </a:solidFill>
+                          <a:latin typeface="Liberation Sans"/>
+                          <a:ea typeface="Liberation Sans"/>
+                          <a:cs typeface="Liberation Sans"/>
+                        </a:rPr>
+                        <a:t>Orta</a:t>
+                      </a:r>
+                    </a:p>
+                  </a:txBody>
+                  <a:tcPr marL="114300" marR="95250" marT="47625" marB="47625" anchor="ctr">
+                    <a:solidFill>
+                      <a:srgbClr val="FFF0CD"/>
+                    </a:solidFill>
+                  </a:tcPr>
+                </a:tc>
+              </a:tr>
+              <a:tr h="685800">
+                <a:tc>
+                  <a:txBody>
+                    <a:bodyPr wrap="square" anchor="ctr">
+                      <a:noAutofit/>
+                    </a:bodyPr>
+                    <a:lstStyle/>
+                    <a:p>
+                      <a:pPr algn="l">
+                        <a:buNone/>
+                      </a:pPr>
+                      <a:r>
+                        <a:rPr sz="1875" b="1">
+                          <a:solidFill>
+                            <a:srgbClr val="26394D"/>
+                          </a:solidFill>
+                          <a:latin typeface="Liberation Sans"/>
+                          <a:ea typeface="Liberation Sans"/>
+                          <a:cs typeface="Liberation Sans"/>
+                        </a:rPr>
+                        <a:t>Depo Otomasyonu</a:t>
+                      </a:r>
+                    </a:p>
+                    <a:p>
+                      <a:pPr algn="l">
+                        <a:buNone/>
+                      </a:pPr>
+                      <a:r>
+                        <a:rPr sz="1875" b="1">
+                          <a:solidFill>
+                            <a:srgbClr val="26394D"/>
+                          </a:solidFill>
+                          <a:latin typeface="Liberation Sans"/>
+                          <a:ea typeface="Liberation Sans"/>
+                          <a:cs typeface="Liberation Sans"/>
+                        </a:rPr>
+                        <a:t>Donanım / yazılım</a:t>
+                      </a:r>
+                    </a:p>
+                  </a:txBody>
+                  <a:tcPr marL="114300" marR="95250" marT="47625" marB="47625" anchor="ctr">
                     <a:solidFill>
                       <a:srgbClr val="FFFFFF"/>
                     </a:solidFill>
@@ -3552,7 +4440,189 @@
                     </a:bodyPr>
                     <a:lstStyle/>
                     <a:p>
-                      <a:pPr algn="l"/>
+                      <a:pPr algn="l">
+                        <a:buNone/>
+                      </a:pPr>
+                      <a:r>
+                        <a:rPr sz="1875" b="0">
+                          <a:solidFill>
+                            <a:srgbClr val="26394D"/>
+                          </a:solidFill>
+                          <a:latin typeface="Liberation Sans"/>
+                          <a:ea typeface="Liberation Sans"/>
+                          <a:cs typeface="Liberation Sans"/>
+                        </a:rPr>
+                        <a:t>52,0%</a:t>
+                      </a:r>
+                    </a:p>
+                    <a:p>
+                      <a:pPr algn="l">
+                        <a:buNone/>
+                      </a:pPr>
+                      <a:r>
+                        <a:rPr sz="1875" b="0">
+                          <a:solidFill>
+                            <a:srgbClr val="26394D"/>
+                          </a:solidFill>
+                          <a:latin typeface="Liberation Sans"/>
+                          <a:ea typeface="Liberation Sans"/>
+                          <a:cs typeface="Liberation Sans"/>
+                        </a:rPr>
+                        <a:t>Plan 63,8%</a:t>
+                      </a:r>
+                    </a:p>
+                  </a:txBody>
+                  <a:tcPr marL="114300" marR="95250" marT="47625" marB="47625" anchor="ctr">
+                    <a:solidFill>
+                      <a:srgbClr val="FFFFFF"/>
+                    </a:solidFill>
+                  </a:tcPr>
+                </a:tc>
+                <a:tc>
+                  <a:txBody>
+                    <a:bodyPr wrap="square" anchor="ctr">
+                      <a:noAutofit/>
+                    </a:bodyPr>
+                    <a:lstStyle/>
+                    <a:p>
+                      <a:pPr algn="l">
+                        <a:buNone/>
+                      </a:pPr>
+                      <a:r>
+                        <a:rPr sz="1875" b="0">
+                          <a:solidFill>
+                            <a:srgbClr val="26394D"/>
+                          </a:solidFill>
+                          <a:latin typeface="Liberation Sans"/>
+                          <a:ea typeface="Liberation Sans"/>
+                          <a:cs typeface="Liberation Sans"/>
+                        </a:rPr>
+                        <a:t>Plan 20.11</a:t>
+                      </a:r>
+                    </a:p>
+                    <a:p>
+                      <a:pPr algn="l">
+                        <a:buNone/>
+                      </a:pPr>
+                      <a:r>
+                        <a:rPr sz="1875" b="0">
+                          <a:solidFill>
+                            <a:srgbClr val="26394D"/>
+                          </a:solidFill>
+                          <a:latin typeface="Liberation Sans"/>
+                          <a:ea typeface="Liberation Sans"/>
+                          <a:cs typeface="Liberation Sans"/>
+                        </a:rPr>
+                        <a:t>04.12 (+14 gün)</a:t>
+                      </a:r>
+                    </a:p>
+                  </a:txBody>
+                  <a:tcPr marL="114300" marR="95250" marT="47625" marB="47625" anchor="ctr">
+                    <a:solidFill>
+                      <a:srgbClr val="FFFFFF"/>
+                    </a:solidFill>
+                  </a:tcPr>
+                </a:tc>
+                <a:tc>
+                  <a:txBody>
+                    <a:bodyPr wrap="square" anchor="ctr">
+                      <a:noAutofit/>
+                    </a:bodyPr>
+                    <a:lstStyle/>
+                    <a:p>
+                      <a:pPr algn="l">
+                        <a:buNone/>
+                      </a:pPr>
+                      <a:r>
+                        <a:rPr sz="1875" b="0">
+                          <a:solidFill>
+                            <a:srgbClr val="26394D"/>
+                          </a:solidFill>
+                          <a:latin typeface="Liberation Sans"/>
+                          <a:ea typeface="Liberation Sans"/>
+                          <a:cs typeface="Liberation Sans"/>
+                        </a:rPr>
+                        <a:t>6 kişi</a:t>
+                      </a:r>
+                    </a:p>
+                    <a:p>
+                      <a:pPr algn="l">
+                        <a:buNone/>
+                      </a:pPr>
+                      <a:r>
+                        <a:rPr sz="1875" b="0">
+                          <a:solidFill>
+                            <a:srgbClr val="26394D"/>
+                          </a:solidFill>
+                          <a:latin typeface="Liberation Sans"/>
+                          <a:ea typeface="Liberation Sans"/>
+                          <a:cs typeface="Liberation Sans"/>
+                        </a:rPr>
+                        <a:t>811 saat</a:t>
+                      </a:r>
+                    </a:p>
+                  </a:txBody>
+                  <a:tcPr marL="114300" marR="95250" marT="47625" marB="47625" anchor="ctr">
+                    <a:solidFill>
+                      <a:srgbClr val="FFFFFF"/>
+                    </a:solidFill>
+                  </a:tcPr>
+                </a:tc>
+                <a:tc>
+                  <a:txBody>
+                    <a:bodyPr wrap="square" anchor="ctr">
+                      <a:noAutofit/>
+                    </a:bodyPr>
+                    <a:lstStyle/>
+                    <a:p>
+                      <a:pPr algn="l">
+                        <a:buNone/>
+                      </a:pPr>
+                      <a:r>
+                        <a:rPr sz="1875" b="0">
+                          <a:solidFill>
+                            <a:srgbClr val="26394D"/>
+                          </a:solidFill>
+                          <a:latin typeface="Liberation Sans"/>
+                          <a:ea typeface="Liberation Sans"/>
+                          <a:cs typeface="Liberation Sans"/>
+                        </a:rPr>
+                        <a:t>Müh. 157 / Ürt. 114 / SA 144</a:t>
+                      </a:r>
+                    </a:p>
+                    <a:p>
+                      <a:pPr algn="l">
+                        <a:buNone/>
+                      </a:pPr>
+                      <a:r>
+                        <a:rPr sz="1875" b="0">
+                          <a:solidFill>
+                            <a:srgbClr val="26394D"/>
+                          </a:solidFill>
+                          <a:latin typeface="Liberation Sans"/>
+                          <a:ea typeface="Liberation Sans"/>
+                          <a:cs typeface="Liberation Sans"/>
+                        </a:rPr>
+                        <a:t>Klt. 155 / PY 112 / BT 129</a:t>
+                      </a:r>
+                    </a:p>
+                  </a:txBody>
+                  <a:tcPr marL="114300" marR="95250" marT="47625" marB="47625" anchor="ctr">
+                    <a:solidFill>
+                      <a:srgbClr val="FFFFFF"/>
+                    </a:solidFill>
+                  </a:tcPr>
+                </a:tc>
+                <a:tc>
+                  <a:txBody>
+                    <a:bodyPr wrap="square" anchor="ctr">
+                      <a:noAutofit/>
+                    </a:bodyPr>
+                    <a:lstStyle/>
+                    <a:p>
+                      <a:pPr algn="l">
+                        <a:buNone/>
+                      </a:pPr>
                       <a:r>
                         <a:rPr sz="1950" b="1">
                           <a:solidFill>
@@ -3566,517 +4636,7 @@
                       </a:r>
                     </a:p>
                   </a:txBody>
-                  <a:tcPr marL="133350" marR="114300" marT="95250" marB="95250" anchor="ctr">
-                    <a:solidFill>
-                      <a:srgbClr val="FCE8EC"/>
-                    </a:solidFill>
-                  </a:tcPr>
-                </a:tc>
-              </a:tr>
-              <a:tr h="1104900">
-                <a:tc>
-                  <a:txBody>
-                    <a:bodyPr wrap="square" anchor="ctr">
-                      <a:noAutofit/>
-                    </a:bodyPr>
-                    <a:lstStyle/>
-                    <a:p>
-                      <a:pPr algn="l"/>
-                      <a:r>
-                        <a:rPr sz="1875" b="1">
-                          <a:solidFill>
-                            <a:srgbClr val="26394D"/>
-                          </a:solidFill>
-                          <a:latin typeface="Liberation Sans"/>
-                          <a:ea typeface="Liberation Sans"/>
-                          <a:cs typeface="Liberation Sans"/>
-                        </a:rPr>
-                        <a:t>Müşteri Portalı</a:t>
-                      </a:r>
-                    </a:p>
-                    <a:p>
-                      <a:pPr algn="l"/>
-                      <a:r>
-                        <a:rPr sz="1875" b="1">
-                          <a:solidFill>
-                            <a:srgbClr val="26394D"/>
-                          </a:solidFill>
-                          <a:latin typeface="Liberation Sans"/>
-                          <a:ea typeface="Liberation Sans"/>
-                          <a:cs typeface="Liberation Sans"/>
-                        </a:rPr>
-                        <a:t>Geliştirme</a:t>
-                      </a:r>
-                    </a:p>
-                  </a:txBody>
-                  <a:tcPr marL="133350" marR="114300" marT="95250" marB="95250" anchor="ctr">
-                    <a:solidFill>
-                      <a:srgbClr val="F2F6FB"/>
-                    </a:solidFill>
-                  </a:tcPr>
-                </a:tc>
-                <a:tc>
-                  <a:txBody>
-                    <a:bodyPr wrap="square" anchor="ctr">
-                      <a:noAutofit/>
-                    </a:bodyPr>
-                    <a:lstStyle/>
-                    <a:p>
-                      <a:pPr algn="l"/>
-                      <a:r>
-                        <a:rPr sz="1875" b="0">
-                          <a:solidFill>
-                            <a:srgbClr val="26394D"/>
-                          </a:solidFill>
-                          <a:latin typeface="Liberation Sans"/>
-                          <a:ea typeface="Liberation Sans"/>
-                          <a:cs typeface="Liberation Sans"/>
-                        </a:rPr>
-                        <a:t>47,5%</a:t>
-                      </a:r>
-                    </a:p>
-                    <a:p>
-                      <a:pPr algn="l"/>
-                      <a:r>
-                        <a:rPr sz="1875" b="0">
-                          <a:solidFill>
-                            <a:srgbClr val="26394D"/>
-                          </a:solidFill>
-                          <a:latin typeface="Liberation Sans"/>
-                          <a:ea typeface="Liberation Sans"/>
-                          <a:cs typeface="Liberation Sans"/>
-                        </a:rPr>
-                        <a:t>Plan 44,8%</a:t>
-                      </a:r>
-                    </a:p>
-                  </a:txBody>
-                  <a:tcPr marL="133350" marR="114300" marT="95250" marB="95250" anchor="ctr">
-                    <a:solidFill>
-                      <a:srgbClr val="F2F6FB"/>
-                    </a:solidFill>
-                  </a:tcPr>
-                </a:tc>
-                <a:tc>
-                  <a:txBody>
-                    <a:bodyPr wrap="square" anchor="ctr">
-                      <a:noAutofit/>
-                    </a:bodyPr>
-                    <a:lstStyle/>
-                    <a:p>
-                      <a:pPr algn="l"/>
-                      <a:r>
-                        <a:rPr sz="1875" b="0">
-                          <a:solidFill>
-                            <a:srgbClr val="26394D"/>
-                          </a:solidFill>
-                          <a:latin typeface="Liberation Sans"/>
-                          <a:ea typeface="Liberation Sans"/>
-                          <a:cs typeface="Liberation Sans"/>
-                        </a:rPr>
-                        <a:t>Plan 27.11</a:t>
-                      </a:r>
-                    </a:p>
-                    <a:p>
-                      <a:pPr algn="l"/>
-                      <a:r>
-                        <a:rPr sz="1875" b="0">
-                          <a:solidFill>
-                            <a:srgbClr val="26394D"/>
-                          </a:solidFill>
-                          <a:latin typeface="Liberation Sans"/>
-                          <a:ea typeface="Liberation Sans"/>
-                          <a:cs typeface="Liberation Sans"/>
-                        </a:rPr>
-                        <a:t>Güncel 27.11</a:t>
-                      </a:r>
-                    </a:p>
-                    <a:p>
-                      <a:pPr algn="l"/>
-                      <a:r>
-                        <a:rPr sz="1875" b="0">
-                          <a:solidFill>
-                            <a:srgbClr val="26394D"/>
-                          </a:solidFill>
-                          <a:latin typeface="Liberation Sans"/>
-                          <a:ea typeface="Liberation Sans"/>
-                          <a:cs typeface="Liberation Sans"/>
-                        </a:rPr>
-                        <a:t>Planında</a:t>
-                      </a:r>
-                    </a:p>
-                  </a:txBody>
-                  <a:tcPr marL="133350" marR="114300" marT="95250" marB="95250" anchor="ctr">
-                    <a:solidFill>
-                      <a:srgbClr val="F2F6FB"/>
-                    </a:solidFill>
-                  </a:tcPr>
-                </a:tc>
-                <a:tc>
-                  <a:txBody>
-                    <a:bodyPr wrap="square" anchor="ctr">
-                      <a:noAutofit/>
-                    </a:bodyPr>
-                    <a:lstStyle/>
-                    <a:p>
-                      <a:pPr algn="l"/>
-                      <a:r>
-                        <a:rPr sz="1875" b="0">
-                          <a:solidFill>
-                            <a:srgbClr val="26394D"/>
-                          </a:solidFill>
-                          <a:latin typeface="Liberation Sans"/>
-                          <a:ea typeface="Liberation Sans"/>
-                          <a:cs typeface="Liberation Sans"/>
-                        </a:rPr>
-                        <a:t>4 kişi</a:t>
-                      </a:r>
-                    </a:p>
-                    <a:p>
-                      <a:pPr algn="l"/>
-                      <a:r>
-                        <a:rPr sz="1875" b="0">
-                          <a:solidFill>
-                            <a:srgbClr val="26394D"/>
-                          </a:solidFill>
-                          <a:latin typeface="Liberation Sans"/>
-                          <a:ea typeface="Liberation Sans"/>
-                          <a:cs typeface="Liberation Sans"/>
-                        </a:rPr>
-                        <a:t>536 saat</a:t>
-                      </a:r>
-                    </a:p>
-                  </a:txBody>
-                  <a:tcPr marL="133350" marR="114300" marT="95250" marB="95250" anchor="ctr">
-                    <a:solidFill>
-                      <a:srgbClr val="F2F6FB"/>
-                    </a:solidFill>
-                  </a:tcPr>
-                </a:tc>
-                <a:tc>
-                  <a:txBody>
-                    <a:bodyPr wrap="square" anchor="ctr">
-                      <a:noAutofit/>
-                    </a:bodyPr>
-                    <a:lstStyle/>
-                    <a:p>
-                      <a:pPr algn="l"/>
-                      <a:r>
-                        <a:rPr sz="1875" b="0">
-                          <a:solidFill>
-                            <a:srgbClr val="26394D"/>
-                          </a:solidFill>
-                          <a:latin typeface="Liberation Sans"/>
-                          <a:ea typeface="Liberation Sans"/>
-                          <a:cs typeface="Liberation Sans"/>
-                        </a:rPr>
-                        <a:t>BT 269 / Klt. 155</a:t>
-                      </a:r>
-                    </a:p>
-                    <a:p>
-                      <a:pPr algn="l"/>
-                      <a:r>
-                        <a:rPr sz="1875" b="0">
-                          <a:solidFill>
-                            <a:srgbClr val="26394D"/>
-                          </a:solidFill>
-                          <a:latin typeface="Liberation Sans"/>
-                          <a:ea typeface="Liberation Sans"/>
-                          <a:cs typeface="Liberation Sans"/>
-                        </a:rPr>
-                        <a:t>PY 112</a:t>
-                      </a:r>
-                    </a:p>
-                  </a:txBody>
-                  <a:tcPr marL="133350" marR="114300" marT="95250" marB="95250" anchor="ctr">
-                    <a:solidFill>
-                      <a:srgbClr val="F2F6FB"/>
-                    </a:solidFill>
-                  </a:tcPr>
-                </a:tc>
-                <a:tc>
-                  <a:txBody>
-                    <a:bodyPr wrap="square" anchor="ctr">
-                      <a:noAutofit/>
-                    </a:bodyPr>
-                    <a:lstStyle/>
-                    <a:p>
-                      <a:pPr algn="l"/>
-                      <a:r>
-                        <a:rPr sz="1950" b="1">
-                          <a:solidFill>
-                            <a:srgbClr val="D97706"/>
-                          </a:solidFill>
-                          <a:latin typeface="Liberation Sans"/>
-                          <a:ea typeface="Liberation Sans"/>
-                          <a:cs typeface="Liberation Sans"/>
-                        </a:rPr>
-                        <a:t>Orta</a:t>
-                      </a:r>
-                    </a:p>
-                  </a:txBody>
-                  <a:tcPr marL="133350" marR="114300" marT="95250" marB="95250" anchor="ctr">
-                    <a:solidFill>
-                      <a:srgbClr val="FFF0CD"/>
-                    </a:solidFill>
-                  </a:tcPr>
-                </a:tc>
-              </a:tr>
-              <a:tr h="1104900">
-                <a:tc>
-                  <a:txBody>
-                    <a:bodyPr wrap="square" anchor="ctr">
-                      <a:noAutofit/>
-                    </a:bodyPr>
-                    <a:lstStyle/>
-                    <a:p>
-                      <a:pPr algn="l"/>
-                      <a:r>
-                        <a:rPr sz="1875" b="1">
-                          <a:solidFill>
-                            <a:srgbClr val="26394D"/>
-                          </a:solidFill>
-                          <a:latin typeface="Liberation Sans"/>
-                          <a:ea typeface="Liberation Sans"/>
-                          <a:cs typeface="Liberation Sans"/>
-                        </a:rPr>
-                        <a:t>Depo Otomasyonu</a:t>
-                      </a:r>
-                    </a:p>
-                    <a:p>
-                      <a:pPr algn="l"/>
-                      <a:r>
-                        <a:rPr sz="1875" b="1">
-                          <a:solidFill>
-                            <a:srgbClr val="26394D"/>
-                          </a:solidFill>
-                          <a:latin typeface="Liberation Sans"/>
-                          <a:ea typeface="Liberation Sans"/>
-                          <a:cs typeface="Liberation Sans"/>
-                        </a:rPr>
-                        <a:t>Donanım / yazılım</a:t>
-                      </a:r>
-                    </a:p>
-                  </a:txBody>
-                  <a:tcPr marL="133350" marR="114300" marT="95250" marB="95250" anchor="ctr">
-                    <a:solidFill>
-                      <a:srgbClr val="FFFFFF"/>
-                    </a:solidFill>
-                  </a:tcPr>
-                </a:tc>
-                <a:tc>
-                  <a:txBody>
-                    <a:bodyPr wrap="square" anchor="ctr">
-                      <a:noAutofit/>
-                    </a:bodyPr>
-                    <a:lstStyle/>
-                    <a:p>
-                      <a:pPr algn="l"/>
-                      <a:r>
-                        <a:rPr sz="1875" b="0">
-                          <a:solidFill>
-                            <a:srgbClr val="26394D"/>
-                          </a:solidFill>
-                          <a:latin typeface="Liberation Sans"/>
-                          <a:ea typeface="Liberation Sans"/>
-                          <a:cs typeface="Liberation Sans"/>
-                        </a:rPr>
-                        <a:t>52,0%</a:t>
-                      </a:r>
-                    </a:p>
-                    <a:p>
-                      <a:pPr algn="l"/>
-                      <a:r>
-                        <a:rPr sz="1875" b="0">
-                          <a:solidFill>
-                            <a:srgbClr val="26394D"/>
-                          </a:solidFill>
-                          <a:latin typeface="Liberation Sans"/>
-                          <a:ea typeface="Liberation Sans"/>
-                          <a:cs typeface="Liberation Sans"/>
-                        </a:rPr>
-                        <a:t>Plan 63,8%</a:t>
-                      </a:r>
-                    </a:p>
-                  </a:txBody>
-                  <a:tcPr marL="133350" marR="114300" marT="95250" marB="95250" anchor="ctr">
-                    <a:solidFill>
-                      <a:srgbClr val="FFFFFF"/>
-                    </a:solidFill>
-                  </a:tcPr>
-                </a:tc>
-                <a:tc>
-                  <a:txBody>
-                    <a:bodyPr wrap="square" anchor="ctr">
-                      <a:noAutofit/>
-                    </a:bodyPr>
-                    <a:lstStyle/>
-                    <a:p>
-                      <a:pPr algn="l"/>
-                      <a:r>
-                        <a:rPr sz="1875" b="0">
-                          <a:solidFill>
-                            <a:srgbClr val="26394D"/>
-                          </a:solidFill>
-                          <a:latin typeface="Liberation Sans"/>
-                          <a:ea typeface="Liberation Sans"/>
-                          <a:cs typeface="Liberation Sans"/>
-                        </a:rPr>
-                        <a:t>Plan 20.11</a:t>
-                      </a:r>
-                    </a:p>
-                    <a:p>
-                      <a:pPr algn="l"/>
-                      <a:r>
-                        <a:rPr sz="1875" b="0">
-                          <a:solidFill>
-                            <a:srgbClr val="26394D"/>
-                          </a:solidFill>
-                          <a:latin typeface="Liberation Sans"/>
-                          <a:ea typeface="Liberation Sans"/>
-                          <a:cs typeface="Liberation Sans"/>
-                        </a:rPr>
-                        <a:t>Güncel 04.12</a:t>
-                      </a:r>
-                    </a:p>
-                    <a:p>
-                      <a:pPr algn="l"/>
-                      <a:r>
-                        <a:rPr sz="1875" b="0">
-                          <a:solidFill>
-                            <a:srgbClr val="26394D"/>
-                          </a:solidFill>
-                          <a:latin typeface="Liberation Sans"/>
-                          <a:ea typeface="Liberation Sans"/>
-                          <a:cs typeface="Liberation Sans"/>
-                        </a:rPr>
-                        <a:t>+14 gün</a:t>
-                      </a:r>
-                    </a:p>
-                  </a:txBody>
-                  <a:tcPr marL="133350" marR="114300" marT="95250" marB="95250" anchor="ctr">
-                    <a:solidFill>
-                      <a:srgbClr val="FFFFFF"/>
-                    </a:solidFill>
-                  </a:tcPr>
-                </a:tc>
-                <a:tc>
-                  <a:txBody>
-                    <a:bodyPr wrap="square" anchor="ctr">
-                      <a:noAutofit/>
-                    </a:bodyPr>
-                    <a:lstStyle/>
-                    <a:p>
-                      <a:pPr algn="l"/>
-                      <a:r>
-                        <a:rPr sz="1875" b="0">
-                          <a:solidFill>
-                            <a:srgbClr val="26394D"/>
-                          </a:solidFill>
-                          <a:latin typeface="Liberation Sans"/>
-                          <a:ea typeface="Liberation Sans"/>
-                          <a:cs typeface="Liberation Sans"/>
-                        </a:rPr>
-                        <a:t>6 kişi</a:t>
-                      </a:r>
-                    </a:p>
-                    <a:p>
-                      <a:pPr algn="l"/>
-                      <a:r>
-                        <a:rPr sz="1875" b="0">
-                          <a:solidFill>
-                            <a:srgbClr val="26394D"/>
-                          </a:solidFill>
-                          <a:latin typeface="Liberation Sans"/>
-                          <a:ea typeface="Liberation Sans"/>
-                          <a:cs typeface="Liberation Sans"/>
-                        </a:rPr>
-                        <a:t>811 saat</a:t>
-                      </a:r>
-                    </a:p>
-                  </a:txBody>
-                  <a:tcPr marL="133350" marR="114300" marT="95250" marB="95250" anchor="ctr">
-                    <a:solidFill>
-                      <a:srgbClr val="FFFFFF"/>
-                    </a:solidFill>
-                  </a:tcPr>
-                </a:tc>
-                <a:tc>
-                  <a:txBody>
-                    <a:bodyPr wrap="square" anchor="ctr">
-                      <a:noAutofit/>
-                    </a:bodyPr>
-                    <a:lstStyle/>
-                    <a:p>
-                      <a:pPr algn="l"/>
-                      <a:r>
-                        <a:rPr sz="1875" b="0">
-                          <a:solidFill>
-                            <a:srgbClr val="26394D"/>
-                          </a:solidFill>
-                          <a:latin typeface="Liberation Sans"/>
-                          <a:ea typeface="Liberation Sans"/>
-                          <a:cs typeface="Liberation Sans"/>
-                        </a:rPr>
-                        <a:t>Müh. 157 / Ürt. 114</a:t>
-                      </a:r>
-                    </a:p>
-                    <a:p>
-                      <a:pPr algn="l"/>
-                      <a:r>
-                        <a:rPr sz="1875" b="0">
-                          <a:solidFill>
-                            <a:srgbClr val="26394D"/>
-                          </a:solidFill>
-                          <a:latin typeface="Liberation Sans"/>
-                          <a:ea typeface="Liberation Sans"/>
-                          <a:cs typeface="Liberation Sans"/>
-                        </a:rPr>
-                        <a:t>SA 144 / Klt. 155</a:t>
-                      </a:r>
-                    </a:p>
-                    <a:p>
-                      <a:pPr algn="l"/>
-                      <a:r>
-                        <a:rPr sz="1875" b="0">
-                          <a:solidFill>
-                            <a:srgbClr val="26394D"/>
-                          </a:solidFill>
-                          <a:latin typeface="Liberation Sans"/>
-                          <a:ea typeface="Liberation Sans"/>
-                          <a:cs typeface="Liberation Sans"/>
-                        </a:rPr>
-                        <a:t>PY 112 / BT 129</a:t>
-                      </a:r>
-                    </a:p>
-                  </a:txBody>
-                  <a:tcPr marL="133350" marR="114300" marT="95250" marB="95250" anchor="ctr">
-                    <a:solidFill>
-                      <a:srgbClr val="FFFFFF"/>
-                    </a:solidFill>
-                  </a:tcPr>
-                </a:tc>
-                <a:tc>
-                  <a:txBody>
-                    <a:bodyPr wrap="square" anchor="ctr">
-                      <a:noAutofit/>
-                    </a:bodyPr>
-                    <a:lstStyle/>
-                    <a:p>
-                      <a:pPr algn="l"/>
-                      <a:r>
-                        <a:rPr sz="1950" b="1">
-                          <a:solidFill>
-                            <a:srgbClr val="C23C4B"/>
-                          </a:solidFill>
-                          <a:latin typeface="Liberation Sans"/>
-                          <a:ea typeface="Liberation Sans"/>
-                          <a:cs typeface="Liberation Sans"/>
-                        </a:rPr>
-                        <a:t>Yüksek</a:t>
-                      </a:r>
-                    </a:p>
-                  </a:txBody>
-                  <a:tcPr marL="133350" marR="114300" marT="95250" marB="95250" anchor="ctr">
+                  <a:tcPr marL="114300" marR="95250" marT="47625" marB="47625" anchor="ctr">
                     <a:solidFill>
                       <a:srgbClr val="FCE8EC"/>
                     </a:solidFill>
@@ -4103,7 +4663,7 @@
         </p:nvSpPr>
         <p:spPr>
           <a:xfrm xmlns:a="http://schemas.openxmlformats.org/drawingml/2006/main">
-            <a:off x="457200" y="5905500"/>
+            <a:off x="457200" y="6191250"/>
             <a:ext cx="14325600" cy="304800"/>
           </a:xfrm>
           <a:prstGeom xmlns:a="http://schemas.openxmlformats.org/drawingml/2006/main" prst="rect">
@@ -4121,7 +4681,7 @@
           </a:bodyPr>
           <a:lstStyle xmlns:a="http://schemas.openxmlformats.org/drawingml/2006/main">
             <a:defPPr algn="l">
-              <a:defRPr sz="2025" b="1">
+              <a:defRPr sz="1875" b="1">
                 <a:solidFill>
                   <a:srgbClr val="0D9488"/>
                 </a:solidFill>
@@ -4133,7 +4693,8 @@
           </a:lstStyle>
           <a:p xmlns:a="http://schemas.openxmlformats.org/drawingml/2006/main">
             <a:pPr algn="l">
-              <a:defRPr sz="2025" b="1">
+              <a:buNone/>
+              <a:defRPr sz="1875" b="1">
                 <a:solidFill>
                   <a:srgbClr val="0D9488"/>
                 </a:solidFill>
@@ -4143,7 +4704,7 @@
               </a:defRPr>
             </a:pPr>
             <a:r>
-              <a:rPr sz="2025" b="1">
+              <a:rPr sz="1875" b="1">
                 <a:solidFill>
                   <a:srgbClr val="0D9488"/>
                 </a:solidFill>
@@ -4161,7 +4722,7 @@
           <p:cNvPr id="7" name="">
             <a:extLst xmlns:a="http://schemas.openxmlformats.org/drawingml/2006/main">
               <a:ext uri="{FF2B5EF4-FFF2-40B4-BE49-F238E27FC236}">
-                <a16:creationId xmlns:a16="http://schemas.microsoft.com/office/drawing/2014/main" id="{C7E45800-2E51-4854-8841-35B5905443E4}"/>
+                <a16:creationId xmlns:a16="http://schemas.microsoft.com/office/drawing/2014/main" id="{1F95B819-B4D1-42C6-A402-E8EADDF2091B}"/>
               </a:ext>
             </a:extLst>
           </p:cNvPr>
@@ -4169,8 +4730,8 @@
           <p:nvPr/>
         </p:nvGraphicFramePr>
         <p:xfrm>
-          <a:off xmlns:a="http://schemas.openxmlformats.org/drawingml/2006/main" x="457200" y="6267450"/>
-          <a:ext xmlns:a="http://schemas.openxmlformats.org/drawingml/2006/main" cx="14325600" cy="1781175"/>
+          <a:off xmlns:a="http://schemas.openxmlformats.org/drawingml/2006/main" x="457200" y="6572250"/>
+          <a:ext xmlns:a="http://schemas.openxmlformats.org/drawingml/2006/main" cx="14325600" cy="1714500"/>
         </p:xfrm>
         <a:graphic xmlns:a="http://schemas.openxmlformats.org/drawingml/2006/main">
           <a:graphicData uri="http://schemas.openxmlformats.org/drawingml/2006/table">
@@ -4186,15 +4747,17 @@
                 <a:gridCol w="1524000"/>
                 <a:gridCol w="1943100"/>
               </a:tblGrid>
-              <a:tr h="552450">
-                <a:tc>
-                  <a:txBody>
-                    <a:bodyPr wrap="square" anchor="ctr">
-                      <a:noAutofit/>
-                    </a:bodyPr>
-                    <a:lstStyle/>
-                    <a:p>
-                      <a:pPr algn="l"/>
+              <a:tr h="571500">
+                <a:tc>
+                  <a:txBody>
+                    <a:bodyPr wrap="square" anchor="ctr">
+                      <a:noAutofit/>
+                    </a:bodyPr>
+                    <a:lstStyle/>
+                    <a:p>
+                      <a:pPr algn="l">
+                        <a:buNone/>
+                      </a:pPr>
                       <a:r>
                         <a:rPr sz="1650" b="1">
                           <a:solidFill>
@@ -4208,7 +4771,7 @@
                       </a:r>
                     </a:p>
                   </a:txBody>
-                  <a:tcPr marL="133350" marR="114300" marT="57150" marB="57150" anchor="ctr">
+                  <a:tcPr marL="114300" marR="95250" marT="47625" marB="47625" anchor="ctr">
                     <a:solidFill>
                       <a:srgbClr val="0D9488"/>
                     </a:solidFill>
@@ -4221,7 +4784,9 @@
                     </a:bodyPr>
                     <a:lstStyle/>
                     <a:p>
-                      <a:pPr algn="l"/>
+                      <a:pPr algn="l">
+                        <a:buNone/>
+                      </a:pPr>
                       <a:r>
                         <a:rPr sz="1650" b="1">
                           <a:solidFill>
@@ -4235,7 +4800,9 @@
                       </a:r>
                     </a:p>
                     <a:p>
-                      <a:pPr algn="l"/>
+                      <a:pPr algn="l">
+                        <a:buNone/>
+                      </a:pPr>
                       <a:r>
                         <a:rPr sz="1650" b="1">
                           <a:solidFill>
@@ -4249,7 +4816,7 @@
                       </a:r>
                     </a:p>
                   </a:txBody>
-                  <a:tcPr marL="133350" marR="114300" marT="57150" marB="57150" anchor="ctr">
+                  <a:tcPr marL="114300" marR="95250" marT="47625" marB="47625" anchor="ctr">
                     <a:solidFill>
                       <a:srgbClr val="0D9488"/>
                     </a:solidFill>
@@ -4262,7 +4829,9 @@
                     </a:bodyPr>
                     <a:lstStyle/>
                     <a:p>
-                      <a:pPr algn="l"/>
+                      <a:pPr algn="l">
+                        <a:buNone/>
+                      </a:pPr>
                       <a:r>
                         <a:rPr sz="1650" b="1">
                           <a:solidFill>
@@ -4276,7 +4845,9 @@
                       </a:r>
                     </a:p>
                     <a:p>
-                      <a:pPr algn="l"/>
+                      <a:pPr algn="l">
+                        <a:buNone/>
+                      </a:pPr>
                       <a:r>
                         <a:rPr sz="1650" b="1">
                           <a:solidFill>
@@ -4290,7 +4861,7 @@
                       </a:r>
                     </a:p>
                   </a:txBody>
-                  <a:tcPr marL="133350" marR="114300" marT="57150" marB="57150" anchor="ctr">
+                  <a:tcPr marL="114300" marR="95250" marT="47625" marB="47625" anchor="ctr">
                     <a:solidFill>
                       <a:srgbClr val="0D9488"/>
                     </a:solidFill>
@@ -4303,7 +4874,9 @@
                     </a:bodyPr>
                     <a:lstStyle/>
                     <a:p>
-                      <a:pPr algn="l"/>
+                      <a:pPr algn="l">
+                        <a:buNone/>
+                      </a:pPr>
                       <a:r>
                         <a:rPr sz="1650" b="1">
                           <a:solidFill>
@@ -4317,7 +4890,9 @@
                       </a:r>
                     </a:p>
                     <a:p>
-                      <a:pPr algn="l"/>
+                      <a:pPr algn="l">
+                        <a:buNone/>
+                      </a:pPr>
                       <a:r>
                         <a:rPr sz="1650" b="1">
                           <a:solidFill>
@@ -4331,7 +4906,7 @@
                       </a:r>
                     </a:p>
                   </a:txBody>
-                  <a:tcPr marL="133350" marR="114300" marT="57150" marB="57150" anchor="ctr">
+                  <a:tcPr marL="114300" marR="95250" marT="47625" marB="47625" anchor="ctr">
                     <a:solidFill>
                       <a:srgbClr val="0D9488"/>
                     </a:solidFill>
@@ -4344,7 +4919,9 @@
                     </a:bodyPr>
                     <a:lstStyle/>
                     <a:p>
-                      <a:pPr algn="l"/>
+                      <a:pPr algn="l">
+                        <a:buNone/>
+                      </a:pPr>
                       <a:r>
                         <a:rPr sz="1650" b="1">
                           <a:solidFill>
@@ -4358,7 +4935,9 @@
                       </a:r>
                     </a:p>
                     <a:p>
-                      <a:pPr algn="l"/>
+                      <a:pPr algn="l">
+                        <a:buNone/>
+                      </a:pPr>
                       <a:r>
                         <a:rPr sz="1650" b="1">
                           <a:solidFill>
@@ -4372,7 +4951,7 @@
                       </a:r>
                     </a:p>
                   </a:txBody>
-                  <a:tcPr marL="133350" marR="114300" marT="57150" marB="57150" anchor="ctr">
+                  <a:tcPr marL="114300" marR="95250" marT="47625" marB="47625" anchor="ctr">
                     <a:solidFill>
                       <a:srgbClr val="0D9488"/>
                     </a:solidFill>
@@ -4385,7 +4964,9 @@
                     </a:bodyPr>
                     <a:lstStyle/>
                     <a:p>
-                      <a:pPr algn="l"/>
+                      <a:pPr algn="l">
+                        <a:buNone/>
+                      </a:pPr>
                       <a:r>
                         <a:rPr sz="1650" b="1">
                           <a:solidFill>
@@ -4399,7 +4980,9 @@
                       </a:r>
                     </a:p>
                     <a:p>
-                      <a:pPr algn="l"/>
+                      <a:pPr algn="l">
+                        <a:buNone/>
+                      </a:pPr>
                       <a:r>
                         <a:rPr sz="1650" b="1">
                           <a:solidFill>
@@ -4413,7 +4996,7 @@
                       </a:r>
                     </a:p>
                   </a:txBody>
-                  <a:tcPr marL="133350" marR="114300" marT="57150" marB="57150" anchor="ctr">
+                  <a:tcPr marL="114300" marR="95250" marT="47625" marB="47625" anchor="ctr">
                     <a:solidFill>
                       <a:srgbClr val="0D9488"/>
                     </a:solidFill>
@@ -4426,7 +5009,9 @@
                     </a:bodyPr>
                     <a:lstStyle/>
                     <a:p>
-                      <a:pPr algn="l"/>
+                      <a:pPr algn="l">
+                        <a:buNone/>
+                      </a:pPr>
                       <a:r>
                         <a:rPr sz="1650" b="1">
                           <a:solidFill>
@@ -4440,7 +5025,7 @@
                       </a:r>
                     </a:p>
                   </a:txBody>
-                  <a:tcPr marL="133350" marR="114300" marT="57150" marB="57150" anchor="ctr">
+                  <a:tcPr marL="114300" marR="95250" marT="47625" marB="47625" anchor="ctr">
                     <a:solidFill>
                       <a:srgbClr val="0D9488"/>
                     </a:solidFill>
@@ -4453,7 +5038,9 @@
                     </a:bodyPr>
                     <a:lstStyle/>
                     <a:p>
-                      <a:pPr algn="l"/>
+                      <a:pPr algn="l">
+                        <a:buNone/>
+                      </a:pPr>
                       <a:r>
                         <a:rPr sz="1650" b="1">
                           <a:solidFill>
@@ -4467,7 +5054,9 @@
                       </a:r>
                     </a:p>
                     <a:p>
-                      <a:pPr algn="l"/>
+                      <a:pPr algn="l">
+                        <a:buNone/>
+                      </a:pPr>
                       <a:r>
                         <a:rPr sz="1650" b="1">
                           <a:solidFill>
@@ -4481,22 +5070,24 @@
                       </a:r>
                     </a:p>
                   </a:txBody>
-                  <a:tcPr marL="133350" marR="114300" marT="57150" marB="57150" anchor="ctr">
+                  <a:tcPr marL="114300" marR="95250" marT="47625" marB="47625" anchor="ctr">
                     <a:solidFill>
                       <a:srgbClr val="0D9488"/>
                     </a:solidFill>
                   </a:tcPr>
                 </a:tc>
               </a:tr>
-              <a:tr h="409575">
-                <a:tc>
-                  <a:txBody>
-                    <a:bodyPr wrap="square" anchor="ctr">
-                      <a:noAutofit/>
-                    </a:bodyPr>
-                    <a:lstStyle/>
-                    <a:p>
-                      <a:pPr algn="l"/>
+              <a:tr h="381000">
+                <a:tc>
+                  <a:txBody>
+                    <a:bodyPr wrap="square" anchor="ctr">
+                      <a:noAutofit/>
+                    </a:bodyPr>
+                    <a:lstStyle/>
+                    <a:p>
+                      <a:pPr algn="l">
+                        <a:buNone/>
+                      </a:pPr>
                       <a:r>
                         <a:rPr sz="1725" b="1">
                           <a:solidFill>
@@ -4510,7 +5101,7 @@
                       </a:r>
                     </a:p>
                   </a:txBody>
-                  <a:tcPr marL="133350" marR="114300" marT="95250" marB="95250" anchor="ctr">
+                  <a:tcPr marL="114300" marR="95250" marT="47625" marB="47625" anchor="ctr">
                     <a:solidFill>
                       <a:srgbClr val="FFFFFF"/>
                     </a:solidFill>
@@ -4523,7 +5114,9 @@
                     </a:bodyPr>
                     <a:lstStyle/>
                     <a:p>
-                      <a:pPr algn="l"/>
+                      <a:pPr algn="l">
+                        <a:buNone/>
+                      </a:pPr>
                       <a:r>
                         <a:rPr sz="1725" b="0">
                           <a:solidFill>
@@ -4537,7 +5130,7 @@
                       </a:r>
                     </a:p>
                   </a:txBody>
-                  <a:tcPr marL="133350" marR="114300" marT="95250" marB="95250" anchor="ctr">
+                  <a:tcPr marL="114300" marR="95250" marT="47625" marB="47625" anchor="ctr">
                     <a:solidFill>
                       <a:srgbClr val="FFFFFF"/>
                     </a:solidFill>
@@ -4550,7 +5143,9 @@
                     </a:bodyPr>
                     <a:lstStyle/>
                     <a:p>
-                      <a:pPr algn="l"/>
+                      <a:pPr algn="l">
+                        <a:buNone/>
+                      </a:pPr>
                       <a:r>
                         <a:rPr sz="1725" b="0">
                           <a:solidFill>
@@ -4564,7 +5159,7 @@
                       </a:r>
                     </a:p>
                   </a:txBody>
-                  <a:tcPr marL="133350" marR="114300" marT="95250" marB="95250" anchor="ctr">
+                  <a:tcPr marL="114300" marR="95250" marT="47625" marB="47625" anchor="ctr">
                     <a:solidFill>
                       <a:srgbClr val="FFFFFF"/>
                     </a:solidFill>
@@ -4577,7 +5172,9 @@
                     </a:bodyPr>
                     <a:lstStyle/>
                     <a:p>
-                      <a:pPr algn="l"/>
+                      <a:pPr algn="l">
+                        <a:buNone/>
+                      </a:pPr>
                       <a:r>
                         <a:rPr sz="1725" b="0">
                           <a:solidFill>
@@ -4591,7 +5188,7 @@
                       </a:r>
                     </a:p>
                   </a:txBody>
-                  <a:tcPr marL="133350" marR="114300" marT="95250" marB="95250" anchor="ctr">
+                  <a:tcPr marL="114300" marR="95250" marT="47625" marB="47625" anchor="ctr">
                     <a:solidFill>
                       <a:srgbClr val="FFFFFF"/>
                     </a:solidFill>
@@ -4604,7 +5201,9 @@
                     </a:bodyPr>
                     <a:lstStyle/>
                     <a:p>
-                      <a:pPr algn="l"/>
+                      <a:pPr algn="l">
+                        <a:buNone/>
+                      </a:pPr>
                       <a:r>
                         <a:rPr sz="1725" b="0">
                           <a:solidFill>
@@ -4618,7 +5217,7 @@
                       </a:r>
                     </a:p>
                   </a:txBody>
-                  <a:tcPr marL="133350" marR="114300" marT="95250" marB="95250" anchor="ctr">
+                  <a:tcPr marL="114300" marR="95250" marT="47625" marB="47625" anchor="ctr">
                     <a:solidFill>
                       <a:srgbClr val="FFFFFF"/>
                     </a:solidFill>
@@ -4631,7 +5230,9 @@
                     </a:bodyPr>
                     <a:lstStyle/>
                     <a:p>
-                      <a:pPr algn="l"/>
+                      <a:pPr algn="l">
+                        <a:buNone/>
+                      </a:pPr>
                       <a:r>
                         <a:rPr sz="1725" b="0">
                           <a:solidFill>
@@ -4645,7 +5246,7 @@
                       </a:r>
                     </a:p>
                   </a:txBody>
-                  <a:tcPr marL="133350" marR="114300" marT="95250" marB="95250" anchor="ctr">
+                  <a:tcPr marL="114300" marR="95250" marT="47625" marB="47625" anchor="ctr">
                     <a:solidFill>
                       <a:srgbClr val="FFFFFF"/>
                     </a:solidFill>
@@ -4658,7 +5259,9 @@
                     </a:bodyPr>
                     <a:lstStyle/>
                     <a:p>
-                      <a:pPr algn="l"/>
+                      <a:pPr algn="l">
+                        <a:buNone/>
+                      </a:pPr>
                       <a:r>
                         <a:rPr sz="1725" b="0">
                           <a:solidFill>
@@ -4672,7 +5275,7 @@
                       </a:r>
                     </a:p>
                   </a:txBody>
-                  <a:tcPr marL="133350" marR="114300" marT="95250" marB="95250" anchor="ctr">
+                  <a:tcPr marL="114300" marR="95250" marT="47625" marB="47625" anchor="ctr">
                     <a:solidFill>
                       <a:srgbClr val="FFFFFF"/>
                     </a:solidFill>
@@ -4685,7 +5288,9 @@
                     </a:bodyPr>
                     <a:lstStyle/>
                     <a:p>
-                      <a:pPr algn="l"/>
+                      <a:pPr algn="l">
+                        <a:buNone/>
+                      </a:pPr>
                       <a:r>
                         <a:rPr sz="1725" b="0">
                           <a:solidFill>
@@ -4699,22 +5304,24 @@
                       </a:r>
                     </a:p>
                   </a:txBody>
-                  <a:tcPr marL="133350" marR="114300" marT="95250" marB="95250" anchor="ctr">
+                  <a:tcPr marL="114300" marR="95250" marT="47625" marB="47625" anchor="ctr">
                     <a:solidFill>
                       <a:srgbClr val="FFFFFF"/>
                     </a:solidFill>
                   </a:tcPr>
                 </a:tc>
               </a:tr>
-              <a:tr h="409575">
-                <a:tc>
-                  <a:txBody>
-                    <a:bodyPr wrap="square" anchor="ctr">
-                      <a:noAutofit/>
-                    </a:bodyPr>
-                    <a:lstStyle/>
-                    <a:p>
-                      <a:pPr algn="l"/>
+              <a:tr h="381000">
+                <a:tc>
+                  <a:txBody>
+                    <a:bodyPr wrap="square" anchor="ctr">
+                      <a:noAutofit/>
+                    </a:bodyPr>
+                    <a:lstStyle/>
+                    <a:p>
+                      <a:pPr algn="l">
+                        <a:buNone/>
+                      </a:pPr>
                       <a:r>
                         <a:rPr sz="1725" b="1">
                           <a:solidFill>
@@ -4728,7 +5335,7 @@
                       </a:r>
                     </a:p>
                   </a:txBody>
-                  <a:tcPr marL="133350" marR="114300" marT="95250" marB="95250" anchor="ctr">
+                  <a:tcPr marL="114300" marR="95250" marT="47625" marB="47625" anchor="ctr">
                     <a:solidFill>
                       <a:srgbClr val="F2F6FB"/>
                     </a:solidFill>
@@ -4741,7 +5348,9 @@
                     </a:bodyPr>
                     <a:lstStyle/>
                     <a:p>
-                      <a:pPr algn="l"/>
+                      <a:pPr algn="l">
+                        <a:buNone/>
+                      </a:pPr>
                       <a:r>
                         <a:rPr sz="1725" b="0">
                           <a:solidFill>
@@ -4755,7 +5364,7 @@
                       </a:r>
                     </a:p>
                   </a:txBody>
-                  <a:tcPr marL="133350" marR="114300" marT="95250" marB="95250" anchor="ctr">
+                  <a:tcPr marL="114300" marR="95250" marT="47625" marB="47625" anchor="ctr">
                     <a:solidFill>
                       <a:srgbClr val="F2F6FB"/>
                     </a:solidFill>
@@ -4768,7 +5377,9 @@
                     </a:bodyPr>
                     <a:lstStyle/>
                     <a:p>
-                      <a:pPr algn="l"/>
+                      <a:pPr algn="l">
+                        <a:buNone/>
+                      </a:pPr>
                       <a:r>
                         <a:rPr sz="1725" b="0">
                           <a:solidFill>
@@ -4782,7 +5393,7 @@
                       </a:r>
                     </a:p>
                   </a:txBody>
-                  <a:tcPr marL="133350" marR="114300" marT="95250" marB="95250" anchor="ctr">
+                  <a:tcPr marL="114300" marR="95250" marT="47625" marB="47625" anchor="ctr">
                     <a:solidFill>
                       <a:srgbClr val="F2F6FB"/>
                     </a:solidFill>
@@ -4795,7 +5406,9 @@
                     </a:bodyPr>
                     <a:lstStyle/>
                     <a:p>
-                      <a:pPr algn="l"/>
+                      <a:pPr algn="l">
+                        <a:buNone/>
+                      </a:pPr>
                       <a:r>
                         <a:rPr sz="1725" b="0">
                           <a:solidFill>
@@ -4809,7 +5422,7 @@
                       </a:r>
                     </a:p>
                   </a:txBody>
-                  <a:tcPr marL="133350" marR="114300" marT="95250" marB="95250" anchor="ctr">
+                  <a:tcPr marL="114300" marR="95250" marT="47625" marB="47625" anchor="ctr">
                     <a:solidFill>
                       <a:srgbClr val="F2F6FB"/>
                     </a:solidFill>
@@ -4822,7 +5435,9 @@
                     </a:bodyPr>
                     <a:lstStyle/>
                     <a:p>
-                      <a:pPr algn="l"/>
+                      <a:pPr algn="l">
+                        <a:buNone/>
+                      </a:pPr>
                       <a:r>
                         <a:rPr sz="1725" b="0">
                           <a:solidFill>
@@ -4836,7 +5451,7 @@
                       </a:r>
                     </a:p>
                   </a:txBody>
-                  <a:tcPr marL="133350" marR="114300" marT="95250" marB="95250" anchor="ctr">
+                  <a:tcPr marL="114300" marR="95250" marT="47625" marB="47625" anchor="ctr">
                     <a:solidFill>
                       <a:srgbClr val="F2F6FB"/>
                     </a:solidFill>
@@ -4849,7 +5464,9 @@
                     </a:bodyPr>
                     <a:lstStyle/>
                     <a:p>
-                      <a:pPr algn="l"/>
+                      <a:pPr algn="l">
+                        <a:buNone/>
+                      </a:pPr>
                       <a:r>
                         <a:rPr sz="1725" b="0">
                           <a:solidFill>
@@ -4863,7 +5480,7 @@
                       </a:r>
                     </a:p>
                   </a:txBody>
-                  <a:tcPr marL="133350" marR="114300" marT="95250" marB="95250" anchor="ctr">
+                  <a:tcPr marL="114300" marR="95250" marT="47625" marB="47625" anchor="ctr">
                     <a:solidFill>
                       <a:srgbClr val="F2F6FB"/>
                     </a:solidFill>
@@ -4876,7 +5493,9 @@
                     </a:bodyPr>
                     <a:lstStyle/>
                     <a:p>
-                      <a:pPr algn="l"/>
+                      <a:pPr algn="l">
+                        <a:buNone/>
+                      </a:pPr>
                       <a:r>
                         <a:rPr sz="1725" b="0">
                           <a:solidFill>
@@ -4890,7 +5509,7 @@
                       </a:r>
                     </a:p>
                   </a:txBody>
-                  <a:tcPr marL="133350" marR="114300" marT="95250" marB="95250" anchor="ctr">
+                  <a:tcPr marL="114300" marR="95250" marT="47625" marB="47625" anchor="ctr">
                     <a:solidFill>
                       <a:srgbClr val="F2F6FB"/>
                     </a:solidFill>
@@ -4903,7 +5522,9 @@
                     </a:bodyPr>
                     <a:lstStyle/>
                     <a:p>
-                      <a:pPr algn="l"/>
+                      <a:pPr algn="l">
+                        <a:buNone/>
+                      </a:pPr>
                       <a:r>
                         <a:rPr sz="1725" b="0">
                           <a:solidFill>
@@ -4917,22 +5538,24 @@
                       </a:r>
                     </a:p>
                   </a:txBody>
-                  <a:tcPr marL="133350" marR="114300" marT="95250" marB="95250" anchor="ctr">
+                  <a:tcPr marL="114300" marR="95250" marT="47625" marB="47625" anchor="ctr">
                     <a:solidFill>
                       <a:srgbClr val="FCE8EC"/>
                     </a:solidFill>
                   </a:tcPr>
                 </a:tc>
               </a:tr>
-              <a:tr h="409575">
-                <a:tc>
-                  <a:txBody>
-                    <a:bodyPr wrap="square" anchor="ctr">
-                      <a:noAutofit/>
-                    </a:bodyPr>
-                    <a:lstStyle/>
-                    <a:p>
-                      <a:pPr algn="l"/>
+              <a:tr h="381000">
+                <a:tc>
+                  <a:txBody>
+                    <a:bodyPr wrap="square" anchor="ctr">
+                      <a:noAutofit/>
+                    </a:bodyPr>
+                    <a:lstStyle/>
+                    <a:p>
+                      <a:pPr algn="l">
+                        <a:buNone/>
+                      </a:pPr>
                       <a:r>
                         <a:rPr sz="1725" b="1">
                           <a:solidFill>
@@ -4946,7 +5569,7 @@
                       </a:r>
                     </a:p>
                   </a:txBody>
-                  <a:tcPr marL="133350" marR="114300" marT="95250" marB="95250" anchor="ctr">
+                  <a:tcPr marL="114300" marR="95250" marT="47625" marB="47625" anchor="ctr">
                     <a:solidFill>
                       <a:srgbClr val="FFFFFF"/>
                     </a:solidFill>
@@ -4959,7 +5582,9 @@
                     </a:bodyPr>
                     <a:lstStyle/>
                     <a:p>
-                      <a:pPr algn="l"/>
+                      <a:pPr algn="l">
+                        <a:buNone/>
+                      </a:pPr>
                       <a:r>
                         <a:rPr sz="1725" b="0">
                           <a:solidFill>
@@ -4973,7 +5598,7 @@
                       </a:r>
                     </a:p>
                   </a:txBody>
-                  <a:tcPr marL="133350" marR="114300" marT="95250" marB="95250" anchor="ctr">
+                  <a:tcPr marL="114300" marR="95250" marT="47625" marB="47625" anchor="ctr">
                     <a:solidFill>
                       <a:srgbClr val="FFFFFF"/>
                     </a:solidFill>
@@ -4986,7 +5611,9 @@
                     </a:bodyPr>
                     <a:lstStyle/>
                     <a:p>
-                      <a:pPr algn="l"/>
+                      <a:pPr algn="l">
+                        <a:buNone/>
+                      </a:pPr>
                       <a:r>
                         <a:rPr sz="1725" b="0">
                           <a:solidFill>
@@ -5000,7 +5627,7 @@
                       </a:r>
                     </a:p>
                   </a:txBody>
-                  <a:tcPr marL="133350" marR="114300" marT="95250" marB="95250" anchor="ctr">
+                  <a:tcPr marL="114300" marR="95250" marT="47625" marB="47625" anchor="ctr">
                     <a:solidFill>
                       <a:srgbClr val="FFFFFF"/>
                     </a:solidFill>
@@ -5013,7 +5640,9 @@
                     </a:bodyPr>
                     <a:lstStyle/>
                     <a:p>
-                      <a:pPr algn="l"/>
+                      <a:pPr algn="l">
+                        <a:buNone/>
+                      </a:pPr>
                       <a:r>
                         <a:rPr sz="1725" b="0">
                           <a:solidFill>
@@ -5027,7 +5656,7 @@
                       </a:r>
                     </a:p>
                   </a:txBody>
-                  <a:tcPr marL="133350" marR="114300" marT="95250" marB="95250" anchor="ctr">
+                  <a:tcPr marL="114300" marR="95250" marT="47625" marB="47625" anchor="ctr">
                     <a:solidFill>
                       <a:srgbClr val="FFFFFF"/>
                     </a:solidFill>
@@ -5040,7 +5669,9 @@
                     </a:bodyPr>
                     <a:lstStyle/>
                     <a:p>
-                      <a:pPr algn="l"/>
+                      <a:pPr algn="l">
+                        <a:buNone/>
+                      </a:pPr>
                       <a:r>
                         <a:rPr sz="1725" b="0">
                           <a:solidFill>
@@ -5054,7 +5685,7 @@
                       </a:r>
                     </a:p>
                   </a:txBody>
-                  <a:tcPr marL="133350" marR="114300" marT="95250" marB="95250" anchor="ctr">
+                  <a:tcPr marL="114300" marR="95250" marT="47625" marB="47625" anchor="ctr">
                     <a:solidFill>
                       <a:srgbClr val="FFFFFF"/>
                     </a:solidFill>
@@ -5067,7 +5698,9 @@
                     </a:bodyPr>
                     <a:lstStyle/>
                     <a:p>
-                      <a:pPr algn="l"/>
+                      <a:pPr algn="l">
+                        <a:buNone/>
+                      </a:pPr>
                       <a:r>
                         <a:rPr sz="1725" b="0">
                           <a:solidFill>
@@ -5081,7 +5714,7 @@
                       </a:r>
                     </a:p>
                   </a:txBody>
-                  <a:tcPr marL="133350" marR="114300" marT="95250" marB="95250" anchor="ctr">
+                  <a:tcPr marL="114300" marR="95250" marT="47625" marB="47625" anchor="ctr">
                     <a:solidFill>
                       <a:srgbClr val="FFFFFF"/>
                     </a:solidFill>
@@ -5094,7 +5727,9 @@
                     </a:bodyPr>
                     <a:lstStyle/>
                     <a:p>
-                      <a:pPr algn="l"/>
+                      <a:pPr algn="l">
+                        <a:buNone/>
+                      </a:pPr>
                       <a:r>
                         <a:rPr sz="1725" b="0">
                           <a:solidFill>
@@ -5108,7 +5743,7 @@
                       </a:r>
                     </a:p>
                   </a:txBody>
-                  <a:tcPr marL="133350" marR="114300" marT="95250" marB="95250" anchor="ctr">
+                  <a:tcPr marL="114300" marR="95250" marT="47625" marB="47625" anchor="ctr">
                     <a:solidFill>
                       <a:srgbClr val="FFFFFF"/>
                     </a:solidFill>
@@ -5121,7 +5756,9 @@
                     </a:bodyPr>
                     <a:lstStyle/>
                     <a:p>
-                      <a:pPr algn="l"/>
+                      <a:pPr algn="l">
+                        <a:buNone/>
+                      </a:pPr>
                       <a:r>
                         <a:rPr sz="1725" b="0">
                           <a:solidFill>
@@ -5135,7 +5772,7 @@
                       </a:r>
                     </a:p>
                   </a:txBody>
-                  <a:tcPr marL="133350" marR="114300" marT="95250" marB="95250" anchor="ctr">
+                  <a:tcPr marL="114300" marR="95250" marT="47625" marB="47625" anchor="ctr">
                     <a:solidFill>
                       <a:srgbClr val="FFFFFF"/>
                     </a:solidFill>
@@ -5143,6 +5780,28 @@
                 </a:tc>
               </a:tr>
             </a:tbl>
+          </a:graphicData>
+        </a:graphic>
+      </p:graphicFrame>
+      <p:graphicFrame>
+        <p:nvGraphicFramePr>
+          <p:cNvPr id="9" name="Chart">
+            <a:extLst xmlns:a="http://schemas.openxmlformats.org/drawingml/2006/main">
+              <a:ext uri="{FF2B5EF4-FFF2-40B4-BE49-F238E27FC236}">
+                <a16:creationId xmlns:a16="http://schemas.microsoft.com/office/drawing/2014/main" id="{9D84B420-4BFD-4DAE-93DC-AC8B1042F90D}"/>
+              </a:ext>
+            </a:extLst>
+          </p:cNvPr>
+          <p:cNvGraphicFramePr/>
+          <p:nvPr/>
+        </p:nvGraphicFramePr>
+        <p:xfrm>
+          <a:off xmlns:a="http://schemas.openxmlformats.org/drawingml/2006/main" x="457200" y="1409700"/>
+          <a:ext xmlns:a="http://schemas.openxmlformats.org/drawingml/2006/main" cx="14325600" cy="2019300"/>
+        </p:xfrm>
+        <a:graphic xmlns:a="http://schemas.openxmlformats.org/drawingml/2006/main">
+          <a:graphicData uri="http://schemas.openxmlformats.org/drawingml/2006/chart">
+            <c:chart xmlns:r="http://schemas.openxmlformats.org/officeDocument/2006/relationships" xmlns:c="http://schemas.openxmlformats.org/drawingml/2006/chart" r:id="R77b36aa89cc648a5"/>
           </a:graphicData>
         </a:graphic>
       </p:graphicFrame>
@@ -5221,6 +5880,7 @@
           </a:lstStyle>
           <a:p xmlns:a="http://schemas.openxmlformats.org/drawingml/2006/main">
             <a:pPr algn="l">
+              <a:buNone/>
               <a:defRPr sz="3225" b="1">
                 <a:solidFill>
                   <a:srgbClr val="18324F"/>
@@ -5290,6 +5950,7 @@
           </a:lstStyle>
           <a:p xmlns:a="http://schemas.openxmlformats.org/drawingml/2006/main">
             <a:pPr algn="l">
+              <a:buNone/>
               <a:defRPr sz="1875" b="0">
                 <a:solidFill>
                   <a:srgbClr val="61758A"/>
@@ -5359,6 +6020,7 @@
           </a:lstStyle>
           <a:p xmlns:a="http://schemas.openxmlformats.org/drawingml/2006/main">
             <a:pPr algn="l">
+              <a:buNone/>
               <a:defRPr sz="1725" b="0">
                 <a:solidFill>
                   <a:srgbClr val="61758A"/>
@@ -5399,7 +6061,7 @@
         <p:spPr>
           <a:xfrm xmlns:a="http://schemas.openxmlformats.org/drawingml/2006/main">
             <a:off x="457200" y="1428750"/>
-            <a:ext cx="14325600" cy="381000"/>
+            <a:ext cx="9239250" cy="381000"/>
           </a:xfrm>
           <a:prstGeom xmlns:a="http://schemas.openxmlformats.org/drawingml/2006/main" prst="rect">
             <a:avLst/>
@@ -5428,6 +6090,7 @@
           </a:lstStyle>
           <a:p xmlns:a="http://schemas.openxmlformats.org/drawingml/2006/main">
             <a:pPr algn="l">
+              <a:buNone/>
               <a:defRPr sz="2100" b="1">
                 <a:solidFill>
                   <a:srgbClr val="2563EB"/>
@@ -5456,7 +6119,7 @@
           <p:cNvPr id="5" name="">
             <a:extLst xmlns:a="http://schemas.openxmlformats.org/drawingml/2006/main">
               <a:ext uri="{FF2B5EF4-FFF2-40B4-BE49-F238E27FC236}">
-                <a16:creationId xmlns:a16="http://schemas.microsoft.com/office/drawing/2014/main" id="{1E9ADF62-F57D-4FCA-BB2A-C06BADB256B1}"/>
+                <a16:creationId xmlns:a16="http://schemas.microsoft.com/office/drawing/2014/main" id="{6885AD23-0A87-4404-B77F-8577E5923281}"/>
               </a:ext>
             </a:extLst>
           </p:cNvPr>
@@ -5465,16 +6128,16 @@
         </p:nvGraphicFramePr>
         <p:xfrm>
           <a:off xmlns:a="http://schemas.openxmlformats.org/drawingml/2006/main" x="457200" y="1943100"/>
-          <a:ext xmlns:a="http://schemas.openxmlformats.org/drawingml/2006/main" cx="14325600" cy="2724150"/>
+          <a:ext xmlns:a="http://schemas.openxmlformats.org/drawingml/2006/main" cx="9525000" cy="2724150"/>
         </p:xfrm>
         <a:graphic xmlns:a="http://schemas.openxmlformats.org/drawingml/2006/main">
           <a:graphicData uri="http://schemas.openxmlformats.org/drawingml/2006/table">
             <a:tbl>
               <a:tblPr firstRow="0" bandRow="0"/>
               <a:tblGrid>
-                <a:gridCol w="2667000"/>
-                <a:gridCol w="5829300"/>
-                <a:gridCol w="5829300"/>
+                <a:gridCol w="2095500"/>
+                <a:gridCol w="3619500"/>
+                <a:gridCol w="3810000"/>
               </a:tblGrid>
               <a:tr h="495300">
                 <a:tc>
@@ -5484,7 +6147,9 @@
                     </a:bodyPr>
                     <a:lstStyle/>
                     <a:p>
-                      <a:pPr algn="l"/>
+                      <a:pPr algn="l">
+                        <a:buNone/>
+                      </a:pPr>
                       <a:r>
                         <a:rPr sz="1650" b="1">
                           <a:solidFill>
@@ -5498,7 +6163,7 @@
                       </a:r>
                     </a:p>
                   </a:txBody>
-                  <a:tcPr marL="133350" marR="114300" marT="57150" marB="57150" anchor="ctr">
+                  <a:tcPr marL="114300" marR="95250" marT="66675" marB="66675" anchor="ctr">
                     <a:solidFill>
                       <a:srgbClr val="18324F"/>
                     </a:solidFill>
@@ -5511,7 +6176,9 @@
                     </a:bodyPr>
                     <a:lstStyle/>
                     <a:p>
-                      <a:pPr algn="l"/>
+                      <a:pPr algn="l">
+                        <a:buNone/>
+                      </a:pPr>
                       <a:r>
                         <a:rPr sz="1650" b="1">
                           <a:solidFill>
@@ -5525,7 +6192,7 @@
                       </a:r>
                     </a:p>
                   </a:txBody>
-                  <a:tcPr marL="133350" marR="114300" marT="57150" marB="57150" anchor="ctr">
+                  <a:tcPr marL="114300" marR="95250" marT="66675" marB="66675" anchor="ctr">
                     <a:solidFill>
                       <a:srgbClr val="18324F"/>
                     </a:solidFill>
@@ -5538,7 +6205,9 @@
                     </a:bodyPr>
                     <a:lstStyle/>
                     <a:p>
-                      <a:pPr algn="l"/>
+                      <a:pPr algn="l">
+                        <a:buNone/>
+                      </a:pPr>
                       <a:r>
                         <a:rPr sz="1650" b="1">
                           <a:solidFill>
@@ -5552,7 +6221,7 @@
                       </a:r>
                     </a:p>
                   </a:txBody>
-                  <a:tcPr marL="133350" marR="114300" marT="57150" marB="57150" anchor="ctr">
+                  <a:tcPr marL="114300" marR="95250" marT="66675" marB="66675" anchor="ctr">
                     <a:solidFill>
                       <a:srgbClr val="18324F"/>
                     </a:solidFill>
@@ -5567,7 +6236,9 @@
                     </a:bodyPr>
                     <a:lstStyle/>
                     <a:p>
-                      <a:pPr algn="l"/>
+                      <a:pPr algn="l">
+                        <a:buNone/>
+                      </a:pPr>
                       <a:r>
                         <a:rPr sz="2025" b="1">
                           <a:solidFill>
@@ -5581,7 +6252,7 @@
                       </a:r>
                     </a:p>
                   </a:txBody>
-                  <a:tcPr marL="133350" marR="114300" marT="95250" marB="95250" anchor="ctr">
+                  <a:tcPr marL="114300" marR="95250" marT="66675" marB="66675" anchor="ctr">
                     <a:solidFill>
                       <a:srgbClr val="FFFFFF"/>
                     </a:solidFill>
@@ -5594,7 +6265,9 @@
                     </a:bodyPr>
                     <a:lstStyle/>
                     <a:p>
-                      <a:pPr algn="l"/>
+                      <a:pPr algn="l">
+                        <a:buNone/>
+                      </a:pPr>
                       <a:r>
                         <a:rPr sz="2025" b="0">
                           <a:solidFill>
@@ -5608,7 +6281,7 @@
                       </a:r>
                     </a:p>
                   </a:txBody>
-                  <a:tcPr marL="133350" marR="114300" marT="95250" marB="95250" anchor="ctr">
+                  <a:tcPr marL="114300" marR="95250" marT="66675" marB="66675" anchor="ctr">
                     <a:solidFill>
                       <a:srgbClr val="FFFFFF"/>
                     </a:solidFill>
@@ -5621,7 +6294,9 @@
                     </a:bodyPr>
                     <a:lstStyle/>
                     <a:p>
-                      <a:pPr algn="l"/>
+                      <a:pPr algn="l">
+                        <a:buNone/>
+                      </a:pPr>
                       <a:r>
                         <a:rPr sz="2025" b="0">
                           <a:solidFill>
@@ -5635,7 +6310,7 @@
                       </a:r>
                     </a:p>
                   </a:txBody>
-                  <a:tcPr marL="133350" marR="114300" marT="95250" marB="95250" anchor="ctr">
+                  <a:tcPr marL="114300" marR="95250" marT="66675" marB="66675" anchor="ctr">
                     <a:solidFill>
                       <a:srgbClr val="FFFFFF"/>
                     </a:solidFill>
@@ -5650,7 +6325,9 @@
                     </a:bodyPr>
                     <a:lstStyle/>
                     <a:p>
-                      <a:pPr algn="l"/>
+                      <a:pPr algn="l">
+                        <a:buNone/>
+                      </a:pPr>
                       <a:r>
                         <a:rPr sz="2025" b="1">
                           <a:solidFill>
@@ -5664,7 +6341,7 @@
                       </a:r>
                     </a:p>
                   </a:txBody>
-                  <a:tcPr marL="133350" marR="114300" marT="95250" marB="95250" anchor="ctr">
+                  <a:tcPr marL="114300" marR="95250" marT="66675" marB="66675" anchor="ctr">
                     <a:solidFill>
                       <a:srgbClr val="F2F6FB"/>
                     </a:solidFill>
@@ -5677,7 +6354,9 @@
                     </a:bodyPr>
                     <a:lstStyle/>
                     <a:p>
-                      <a:pPr algn="l"/>
+                      <a:pPr algn="l">
+                        <a:buNone/>
+                      </a:pPr>
                       <a:r>
                         <a:rPr sz="2025" b="0">
                           <a:solidFill>
@@ -5691,7 +6370,7 @@
                       </a:r>
                     </a:p>
                   </a:txBody>
-                  <a:tcPr marL="133350" marR="114300" marT="95250" marB="95250" anchor="ctr">
+                  <a:tcPr marL="114300" marR="95250" marT="66675" marB="66675" anchor="ctr">
                     <a:solidFill>
                       <a:srgbClr val="F2F6FB"/>
                     </a:solidFill>
@@ -5704,7 +6383,9 @@
                     </a:bodyPr>
                     <a:lstStyle/>
                     <a:p>
-                      <a:pPr algn="l"/>
+                      <a:pPr algn="l">
+                        <a:buNone/>
+                      </a:pPr>
                       <a:r>
                         <a:rPr sz="2025" b="0">
                           <a:solidFill>
@@ -5718,7 +6399,7 @@
                       </a:r>
                     </a:p>
                   </a:txBody>
-                  <a:tcPr marL="133350" marR="114300" marT="95250" marB="95250" anchor="ctr">
+                  <a:tcPr marL="114300" marR="95250" marT="66675" marB="66675" anchor="ctr">
                     <a:solidFill>
                       <a:srgbClr val="F2F6FB"/>
                     </a:solidFill>
@@ -5733,7 +6414,9 @@
                     </a:bodyPr>
                     <a:lstStyle/>
                     <a:p>
-                      <a:pPr algn="l"/>
+                      <a:pPr algn="l">
+                        <a:buNone/>
+                      </a:pPr>
                       <a:r>
                         <a:rPr sz="2025" b="1">
                           <a:solidFill>
@@ -5747,7 +6430,7 @@
                       </a:r>
                     </a:p>
                   </a:txBody>
-                  <a:tcPr marL="133350" marR="114300" marT="95250" marB="95250" anchor="ctr">
+                  <a:tcPr marL="114300" marR="95250" marT="66675" marB="66675" anchor="ctr">
                     <a:solidFill>
                       <a:srgbClr val="FFFFFF"/>
                     </a:solidFill>
@@ -5760,7 +6443,9 @@
                     </a:bodyPr>
                     <a:lstStyle/>
                     <a:p>
-                      <a:pPr algn="l"/>
+                      <a:pPr algn="l">
+                        <a:buNone/>
+                      </a:pPr>
                       <a:r>
                         <a:rPr sz="2025" b="0">
                           <a:solidFill>
@@ -5774,7 +6459,7 @@
                       </a:r>
                     </a:p>
                   </a:txBody>
-                  <a:tcPr marL="133350" marR="114300" marT="95250" marB="95250" anchor="ctr">
+                  <a:tcPr marL="114300" marR="95250" marT="66675" marB="66675" anchor="ctr">
                     <a:solidFill>
                       <a:srgbClr val="FFFFFF"/>
                     </a:solidFill>
@@ -5787,7 +6472,9 @@
                     </a:bodyPr>
                     <a:lstStyle/>
                     <a:p>
-                      <a:pPr algn="l"/>
+                      <a:pPr algn="l">
+                        <a:buNone/>
+                      </a:pPr>
                       <a:r>
                         <a:rPr sz="2025" b="0">
                           <a:solidFill>
@@ -5801,7 +6488,7 @@
                       </a:r>
                     </a:p>
                   </a:txBody>
-                  <a:tcPr marL="133350" marR="114300" marT="95250" marB="95250" anchor="ctr">
+                  <a:tcPr marL="114300" marR="95250" marT="66675" marB="66675" anchor="ctr">
                     <a:solidFill>
                       <a:srgbClr val="FFFFFF"/>
                     </a:solidFill>
@@ -5829,7 +6516,7 @@
         <p:spPr>
           <a:xfrm xmlns:a="http://schemas.openxmlformats.org/drawingml/2006/main">
             <a:off x="457200" y="4819650"/>
-            <a:ext cx="14325600" cy="400050"/>
+            <a:ext cx="9048750" cy="400050"/>
           </a:xfrm>
           <a:prstGeom xmlns:a="http://schemas.openxmlformats.org/drawingml/2006/main" prst="rect">
             <a:avLst/>
@@ -5858,6 +6545,7 @@
           </a:lstStyle>
           <a:p xmlns:a="http://schemas.openxmlformats.org/drawingml/2006/main">
             <a:pPr algn="l">
+              <a:buNone/>
               <a:defRPr sz="2700" b="1">
                 <a:solidFill>
                   <a:srgbClr val="D97706"/>
@@ -5886,7 +6574,7 @@
           <p:cNvPr id="7" name="">
             <a:extLst xmlns:a="http://schemas.openxmlformats.org/drawingml/2006/main">
               <a:ext uri="{FF2B5EF4-FFF2-40B4-BE49-F238E27FC236}">
-                <a16:creationId xmlns:a16="http://schemas.microsoft.com/office/drawing/2014/main" id="{26ED37FE-E728-4EA9-BB6F-1A0B5F9440D9}"/>
+                <a16:creationId xmlns:a16="http://schemas.microsoft.com/office/drawing/2014/main" id="{E2A18D66-0CB9-4832-AF97-37EF507763B2}"/>
               </a:ext>
             </a:extLst>
           </p:cNvPr>
@@ -5916,7 +6604,9 @@
                     </a:bodyPr>
                     <a:lstStyle/>
                     <a:p>
-                      <a:pPr algn="l"/>
+                      <a:pPr algn="l">
+                        <a:buNone/>
+                      </a:pPr>
                       <a:r>
                         <a:rPr sz="1650" b="1">
                           <a:solidFill>
@@ -5943,7 +6633,9 @@
                     </a:bodyPr>
                     <a:lstStyle/>
                     <a:p>
-                      <a:pPr algn="l"/>
+                      <a:pPr algn="l">
+                        <a:buNone/>
+                      </a:pPr>
                       <a:r>
                         <a:rPr sz="1650" b="1">
                           <a:solidFill>
@@ -5970,7 +6662,9 @@
                     </a:bodyPr>
                     <a:lstStyle/>
                     <a:p>
-                      <a:pPr algn="l"/>
+                      <a:pPr algn="l">
+                        <a:buNone/>
+                      </a:pPr>
                       <a:r>
                         <a:rPr sz="1650" b="1">
                           <a:solidFill>
@@ -5997,7 +6691,9 @@
                     </a:bodyPr>
                     <a:lstStyle/>
                     <a:p>
-                      <a:pPr algn="l"/>
+                      <a:pPr algn="l">
+                        <a:buNone/>
+                      </a:pPr>
                       <a:r>
                         <a:rPr sz="1650" b="1">
                           <a:solidFill>
@@ -6024,7 +6720,9 @@
                     </a:bodyPr>
                     <a:lstStyle/>
                     <a:p>
-                      <a:pPr algn="l"/>
+                      <a:pPr algn="l">
+                        <a:buNone/>
+                      </a:pPr>
                       <a:r>
                         <a:rPr sz="1650" b="1">
                           <a:solidFill>
@@ -6053,7 +6751,9 @@
                     </a:bodyPr>
                     <a:lstStyle/>
                     <a:p>
-                      <a:pPr algn="l"/>
+                      <a:pPr algn="l">
+                        <a:buNone/>
+                      </a:pPr>
                       <a:r>
                         <a:rPr sz="1875" b="1">
                           <a:solidFill>
@@ -6080,7 +6780,9 @@
                     </a:bodyPr>
                     <a:lstStyle/>
                     <a:p>
-                      <a:pPr algn="l"/>
+                      <a:pPr algn="l">
+                        <a:buNone/>
+                      </a:pPr>
                       <a:r>
                         <a:rPr sz="1875" b="0">
                           <a:solidFill>
@@ -6107,7 +6809,9 @@
                     </a:bodyPr>
                     <a:lstStyle/>
                     <a:p>
-                      <a:pPr algn="l"/>
+                      <a:pPr algn="l">
+                        <a:buNone/>
+                      </a:pPr>
                       <a:r>
                         <a:rPr sz="1875" b="0">
                           <a:solidFill>
@@ -6134,7 +6838,9 @@
                     </a:bodyPr>
                     <a:lstStyle/>
                     <a:p>
-                      <a:pPr algn="l"/>
+                      <a:pPr algn="l">
+                        <a:buNone/>
+                      </a:pPr>
                       <a:r>
                         <a:rPr sz="1875" b="0">
                           <a:solidFill>
@@ -6161,7 +6867,9 @@
                     </a:bodyPr>
                     <a:lstStyle/>
                     <a:p>
-                      <a:pPr algn="l"/>
+                      <a:pPr algn="l">
+                        <a:buNone/>
+                      </a:pPr>
                       <a:r>
                         <a:rPr sz="1875" b="0">
                           <a:solidFill>
@@ -6190,7 +6898,9 @@
                     </a:bodyPr>
                     <a:lstStyle/>
                     <a:p>
-                      <a:pPr algn="l"/>
+                      <a:pPr algn="l">
+                        <a:buNone/>
+                      </a:pPr>
                       <a:r>
                         <a:rPr sz="1875" b="1">
                           <a:solidFill>
@@ -6217,7 +6927,9 @@
                     </a:bodyPr>
                     <a:lstStyle/>
                     <a:p>
-                      <a:pPr algn="l"/>
+                      <a:pPr algn="l">
+                        <a:buNone/>
+                      </a:pPr>
                       <a:r>
                         <a:rPr sz="1875" b="0">
                           <a:solidFill>
@@ -6244,7 +6956,9 @@
                     </a:bodyPr>
                     <a:lstStyle/>
                     <a:p>
-                      <a:pPr algn="l"/>
+                      <a:pPr algn="l">
+                        <a:buNone/>
+                      </a:pPr>
                       <a:r>
                         <a:rPr sz="1875" b="0">
                           <a:solidFill>
@@ -6271,7 +6985,9 @@
                     </a:bodyPr>
                     <a:lstStyle/>
                     <a:p>
-                      <a:pPr algn="l"/>
+                      <a:pPr algn="l">
+                        <a:buNone/>
+                      </a:pPr>
                       <a:r>
                         <a:rPr sz="1875" b="0">
                           <a:solidFill>
@@ -6298,7 +7014,9 @@
                     </a:bodyPr>
                     <a:lstStyle/>
                     <a:p>
-                      <a:pPr algn="l"/>
+                      <a:pPr algn="l">
+                        <a:buNone/>
+                      </a:pPr>
                       <a:r>
                         <a:rPr sz="1875" b="0">
                           <a:solidFill>
@@ -6327,7 +7045,9 @@
                     </a:bodyPr>
                     <a:lstStyle/>
                     <a:p>
-                      <a:pPr algn="l"/>
+                      <a:pPr algn="l">
+                        <a:buNone/>
+                      </a:pPr>
                       <a:r>
                         <a:rPr sz="1875" b="1">
                           <a:solidFill>
@@ -6354,7 +7074,9 @@
                     </a:bodyPr>
                     <a:lstStyle/>
                     <a:p>
-                      <a:pPr algn="l"/>
+                      <a:pPr algn="l">
+                        <a:buNone/>
+                      </a:pPr>
                       <a:r>
                         <a:rPr sz="1875" b="0">
                           <a:solidFill>
@@ -6381,7 +7103,9 @@
                     </a:bodyPr>
                     <a:lstStyle/>
                     <a:p>
-                      <a:pPr algn="l"/>
+                      <a:pPr algn="l">
+                        <a:buNone/>
+                      </a:pPr>
                       <a:r>
                         <a:rPr sz="1875" b="0">
                           <a:solidFill>
@@ -6408,7 +7132,9 @@
                     </a:bodyPr>
                     <a:lstStyle/>
                     <a:p>
-                      <a:pPr algn="l"/>
+                      <a:pPr algn="l">
+                        <a:buNone/>
+                      </a:pPr>
                       <a:r>
                         <a:rPr sz="1875" b="0">
                           <a:solidFill>
@@ -6435,7 +7161,9 @@
                     </a:bodyPr>
                     <a:lstStyle/>
                     <a:p>
-                      <a:pPr algn="l"/>
+                      <a:pPr algn="l">
+                        <a:buNone/>
+                      </a:pPr>
                       <a:r>
                         <a:rPr sz="1875" b="0">
                           <a:solidFill>
@@ -6460,6 +7188,97 @@
           </a:graphicData>
         </a:graphic>
       </p:graphicFrame>
+      <p:graphicFrame>
+        <p:nvGraphicFramePr>
+          <p:cNvPr id="9" name="Chart">
+            <a:extLst xmlns:a="http://schemas.openxmlformats.org/drawingml/2006/main">
+              <a:ext uri="{FF2B5EF4-FFF2-40B4-BE49-F238E27FC236}">
+                <a16:creationId xmlns:a16="http://schemas.microsoft.com/office/drawing/2014/main" id="{6FE23D59-AE16-4C32-9BE7-6858694F3016}"/>
+              </a:ext>
+            </a:extLst>
+          </p:cNvPr>
+          <p:cNvGraphicFramePr/>
+          <p:nvPr/>
+        </p:nvGraphicFramePr>
+        <p:xfrm>
+          <a:off xmlns:a="http://schemas.openxmlformats.org/drawingml/2006/main" x="10287000" y="1619250"/>
+          <a:ext xmlns:a="http://schemas.openxmlformats.org/drawingml/2006/main" cx="4495800" cy="3048000"/>
+        </p:xfrm>
+        <a:graphic xmlns:a="http://schemas.openxmlformats.org/drawingml/2006/main">
+          <a:graphicData uri="http://schemas.openxmlformats.org/drawingml/2006/chart">
+            <c:chart xmlns:r="http://schemas.openxmlformats.org/officeDocument/2006/relationships" xmlns:c="http://schemas.openxmlformats.org/drawingml/2006/chart" r:id="R43517a525cab4fa2"/>
+          </a:graphicData>
+        </a:graphic>
+      </p:graphicFrame>
+      <p:sp>
+        <p:nvSpPr>
+          <p:cNvPr id="10" name="history-entry-note">
+            <a:extLst xmlns:a="http://schemas.openxmlformats.org/drawingml/2006/main">
+              <a:ext uri="{FF2B5EF4-FFF2-40B4-BE49-F238E27FC236}">
+                <a16:creationId xmlns:a16="http://schemas.microsoft.com/office/drawing/2014/main" id="{3D1F87B9-6C8F-486F-A93A-E1093ADEE7FF}"/>
+              </a:ext>
+            </a:extLst>
+          </p:cNvPr>
+          <p:cNvSpPr>
+            <a:spLocks xmlns:a="http://schemas.openxmlformats.org/drawingml/2006/main" noGrp="1"/>
+          </p:cNvSpPr>
+          <p:nvPr/>
+        </p:nvSpPr>
+        <p:spPr>
+          <a:xfrm xmlns:a="http://schemas.openxmlformats.org/drawingml/2006/main">
+            <a:off x="10287000" y="4762500"/>
+            <a:ext cx="4495800" cy="400050"/>
+          </a:xfrm>
+          <a:prstGeom xmlns:a="http://schemas.openxmlformats.org/drawingml/2006/main" prst="rect">
+            <a:avLst/>
+          </a:prstGeom>
+          <a:noFill xmlns:a="http://schemas.openxmlformats.org/drawingml/2006/main"/>
+          <a:ln xmlns:a="http://schemas.openxmlformats.org/drawingml/2006/main" w="0">
+            <a:noFill/>
+            <a:prstDash val="solid"/>
+          </a:ln>
+        </p:spPr>
+        <p:txBody>
+          <a:bodyPr xmlns:a="http://schemas.openxmlformats.org/drawingml/2006/main" wrap="square" lIns="0" tIns="0" rIns="0" bIns="0" anchor="ctr">
+            <a:noAutofit/>
+          </a:bodyPr>
+          <a:lstStyle xmlns:a="http://schemas.openxmlformats.org/drawingml/2006/main">
+            <a:defPPr>
+              <a:defRPr sz="1350" b="0">
+                <a:solidFill>
+                  <a:srgbClr val="61758A"/>
+                </a:solidFill>
+                <a:latin typeface="Liberation Sans"/>
+                <a:ea typeface="Liberation Sans"/>
+                <a:cs typeface="Liberation Sans"/>
+              </a:defRPr>
+            </a:defPPr>
+          </a:lstStyle>
+          <a:p xmlns:a="http://schemas.openxmlformats.org/drawingml/2006/main">
+            <a:pPr>
+              <a:defRPr sz="1350" b="0">
+                <a:solidFill>
+                  <a:srgbClr val="61758A"/>
+                </a:solidFill>
+                <a:latin typeface="Liberation Sans"/>
+                <a:ea typeface="Liberation Sans"/>
+                <a:cs typeface="Liberation Sans"/>
+              </a:defRPr>
+            </a:pPr>
+            <a:r>
+              <a:rPr sz="1350" b="0">
+                <a:solidFill>
+                  <a:srgbClr val="61758A"/>
+                </a:solidFill>
+                <a:latin typeface="Liberation Sans"/>
+                <a:ea typeface="Liberation Sans"/>
+                <a:cs typeface="Liberation Sans"/>
+              </a:rPr>
+              <a:t>Yeni hafta ve oranı, grafiğin veri tablosuna ekleyin.</a:t>
+            </a:r>
+          </a:p>
+        </p:txBody>
+      </p:sp>
     </p:spTree>
     <p:extLst>
       <p:ext uri="{BB962C8B-B14F-4D97-AF65-F5344CB8AC3E}">

</xml_diff>